<commit_message>
Deck Marketing: lámina 12 con el mal manejo de Braze en ocho datos
Co-Authored-By: Claude Opus 5.5 <noreply@anthropic.com>
Claude-Session: https://claude.ai/code/session_01TvUEpjnhb8DCD8seX9ZHQA
</commit_message>
<xml_diff>
--- a/braze-analysis/deck/v6/marketing/DECK_marketing.pptx
+++ b/braze-analysis/deck/v6/marketing/DECK_marketing.pptx
@@ -17,9 +17,10 @@
     <p:sldId id="265" r:id="rId11"/>
     <p:sldId id="266" r:id="rId12"/>
     <p:sldId id="267" r:id="rId13"/>
+    <p:sldId id="268" r:id="rId14"/>
   </p:sldIdLst>
   <p:notesMasterIdLst>
-    <p:notesMasterId r:id="rId14"/>
+    <p:notesMasterId r:id="rId15"/>
   </p:notesMasterIdLst>
   <p:sldSz cx="12192000" cy="6858000"/>
   <p:notesSz cx="6858000" cy="12192000"/>
@@ -118,7 +119,7 @@
   <p:extLst>
     <p:ext uri="{521415D9-36F7-43E2-AB2F-B90AF26B5E84}">
       <p14:sectionLst xmlns:p14="http://schemas.microsoft.com/office/powerpoint/2010/main">
-        <p14:section name="Inicio" id="{a5c43540-35d7-73ce-757f-7b5fb0ebce84}">
+        <p14:section name="Inicio" id="{10d54e60-fa37-03ee-8f16-65a60b84a059}">
           <p14:sldIdLst>
             <p14:sldId id="256"/>
             <p14:sldId id="257"/>
@@ -132,6 +133,7 @@
             <p14:sldId id="265"/>
             <p14:sldId id="266"/>
             <p14:sldId id="267"/>
+            <p14:sldId id="268"/>
           </p14:sldIdLst>
         </p14:section>
       </p14:sectionLst>
@@ -826,6 +828,94 @@
             <a:fld id="{F7021451-1387-4CA6-816F-3879F97B5CBC}" type="slidenum">
               <a:rPr lang="en-US"/>
               <a:t>12</a:t>
+            </a:fld>
+            <a:endParaRPr lang="en-US"/>
+          </a:p>
+        </p:txBody>
+      </p:sp>
+    </p:spTree>
+    <p:extLst>
+      <p:ext uri="{BB962C8B-B14F-4D97-AF65-F5344CB8AC3E}">
+        <p14:creationId xmlns:p14="http://schemas.microsoft.com/office/powerpoint/2010/main" val="1024086991"/>
+      </p:ext>
+    </p:extLst>
+  </p:cSld>
+  <p:clrMapOvr>
+    <a:masterClrMapping/>
+  </p:clrMapOvr>
+</p:notes>
+</file>
+
+<file path=ppt/notesSlides/notesSlide13.xml><?xml version="1.0" encoding="utf-8"?>
+<p:notes xmlns:a="http://schemas.openxmlformats.org/drawingml/2006/main" xmlns:r="http://schemas.openxmlformats.org/officeDocument/2006/relationships" xmlns:p="http://schemas.openxmlformats.org/presentationml/2006/main">
+  <p:cSld>
+    <p:spTree>
+      <p:nvGrpSpPr>
+        <p:cNvPr id="1" name=""/>
+        <p:cNvGrpSpPr/>
+        <p:nvPr/>
+      </p:nvGrpSpPr>
+      <p:grpSpPr>
+        <a:xfrm>
+          <a:off x="0" y="0"/>
+          <a:ext cx="0" cy="0"/>
+          <a:chOff x="0" y="0"/>
+          <a:chExt cx="0" cy="0"/>
+        </a:xfrm>
+      </p:grpSpPr>
+      <p:sp>
+        <p:nvSpPr>
+          <p:cNvPr id="2" name="Slide Image Placeholder 1"/>
+          <p:cNvSpPr>
+            <a:spLocks noGrp="1" noRot="1" noChangeAspect="1"/>
+          </p:cNvSpPr>
+          <p:nvPr>
+            <p:ph type="sldImg"/>
+          </p:nvPr>
+        </p:nvSpPr>
+        <p:spPr/>
+      </p:sp>
+      <p:sp>
+        <p:nvSpPr>
+          <p:cNvPr id="3" name="Notes Placeholder 2"/>
+          <p:cNvSpPr>
+            <a:spLocks noGrp="1"/>
+          </p:cNvSpPr>
+          <p:nvPr>
+            <p:ph type="body" idx="1"/>
+          </p:nvPr>
+        </p:nvSpPr>
+        <p:spPr/>
+        <p:txBody>
+          <a:bodyPr/>
+          <a:lstStyle/>
+          <a:p>
+            <a:r>
+              <a:rPr lang="en-US" dirty="0"/>
+              <a:t/>
+            </a:r>
+            <a:endParaRPr lang="en-US" dirty="0"/>
+          </a:p>
+        </p:txBody>
+      </p:sp>
+      <p:sp>
+        <p:nvSpPr>
+          <p:cNvPr id="4" name="Slide Number Placeholder 3"/>
+          <p:cNvSpPr>
+            <a:spLocks noGrp="1"/>
+          </p:cNvSpPr>
+          <p:nvPr>
+            <p:ph type="sldNum" sz="quarter" idx="10"/>
+          </p:nvPr>
+        </p:nvSpPr>
+        <p:spPr/>
+        <p:txBody>
+          <a:bodyPr/>
+          <a:lstStyle/>
+          <a:p>
+            <a:fld id="{F7021451-1387-4CA6-816F-3879F97B5CBC}" type="slidenum">
+              <a:rPr lang="en-US"/>
+              <a:t>13</a:t>
             </a:fld>
             <a:endParaRPr lang="en-US"/>
           </a:p>
@@ -4220,7 +4310,7 @@
         <p:spPr>
           <a:xfrm>
             <a:off x="511956" y="390033"/>
-            <a:ext cx="11521105" cy="661609"/>
+            <a:ext cx="11521105" cy="330805"/>
           </a:xfrm>
           <a:prstGeom prst="rect">
             <a:avLst/>
@@ -4247,7 +4337,7 @@
                 <a:ea typeface="Inter" pitchFamily="34" charset="-122"/>
                 <a:cs typeface="Inter" pitchFamily="34" charset="-120"/>
               </a:rPr>
-              <a:t>Qué lo explica: escribimos por lo que queremos vender, cada equipo por su cuenta y sin medir</a:t>
+              <a:t>Braze no tiene dueño ni reglas comunes, y se nota en ocho datos de la cuenta</a:t>
             </a:r>
             <a:endParaRPr lang="en-US" sz="2210" dirty="0"/>
           </a:p>
@@ -4261,320 +4351,8 @@
         </p:nvSpPr>
         <p:spPr>
           <a:xfrm>
-            <a:off x="511956" y="1161358"/>
-            <a:ext cx="3527477" cy="1398573"/>
-          </a:xfrm>
-          <a:prstGeom prst="rect">
-            <a:avLst/>
-          </a:prstGeom>
-          <a:solidFill>
-            <a:srgbClr val="F4F6F9"/>
-          </a:solidFill>
-          <a:ln/>
-        </p:spPr>
-      </p:sp>
-      <p:sp>
-        <p:nvSpPr>
-          <p:cNvPr id="4" name="Text 2"/>
-          <p:cNvSpPr txBox="1"/>
-          <p:nvPr/>
-        </p:nvSpPr>
-        <p:spPr>
-          <a:xfrm>
-            <a:off x="694765" y="1356374"/>
-            <a:ext cx="3275003" cy="512107"/>
-          </a:xfrm>
-          <a:prstGeom prst="rect">
-            <a:avLst/>
-          </a:prstGeom>
-          <a:noFill/>
-          <a:ln/>
-        </p:spPr>
-        <p:txBody>
-          <a:bodyPr wrap="square" lIns="0" tIns="0" rIns="0" bIns="0" rtlCol="0" anchor="t"/>
-          <a:lstStyle/>
-          <a:p>
-            <a:pPr algn="l" indent="0" marL="0">
-              <a:lnSpc>
-                <a:spcPct val="83000"/>
-              </a:lnSpc>
-              <a:buNone/>
-            </a:pPr>
-            <a:r>
-              <a:rPr lang="en-US" sz="4030" b="1" spc="-80" kern="0" dirty="0">
-                <a:solidFill>
-                  <a:srgbClr val="0B1220"/>
-                </a:solidFill>
-                <a:latin typeface="Inter" pitchFamily="34" charset="0"/>
-                <a:ea typeface="Inter" pitchFamily="34" charset="-122"/>
-                <a:cs typeface="Inter" pitchFamily="34" charset="-120"/>
-              </a:rPr>
-              <a:t>73 %</a:t>
-            </a:r>
-            <a:endParaRPr lang="en-US" sz="4030" dirty="0"/>
-          </a:p>
-        </p:txBody>
-      </p:sp>
-      <p:sp>
-        <p:nvSpPr>
-          <p:cNvPr id="5" name="Text 3"/>
-          <p:cNvSpPr txBox="1"/>
-          <p:nvPr/>
-        </p:nvSpPr>
-        <p:spPr>
-          <a:xfrm>
-            <a:off x="694765" y="1953782"/>
-            <a:ext cx="3275003" cy="411132"/>
-          </a:xfrm>
-          <a:prstGeom prst="rect">
-            <a:avLst/>
-          </a:prstGeom>
-          <a:noFill/>
-          <a:ln/>
-        </p:spPr>
-        <p:txBody>
-          <a:bodyPr wrap="square" lIns="0" tIns="0" rIns="0" bIns="0" rtlCol="0" anchor="t"/>
-          <a:lstStyle/>
-          <a:p>
-            <a:pPr algn="l" indent="0" marL="0">
-              <a:lnSpc>
-                <a:spcPct val="112000"/>
-              </a:lnSpc>
-              <a:buNone/>
-            </a:pPr>
-            <a:r>
-              <a:rPr lang="en-US" sz="1200" dirty="0">
-                <a:solidFill>
-                  <a:srgbClr val="0B1220"/>
-                </a:solidFill>
-                <a:latin typeface="Inter" pitchFamily="34" charset="0"/>
-                <a:ea typeface="Inter" pitchFamily="34" charset="-122"/>
-                <a:cs typeface="Inter" pitchFamily="34" charset="-120"/>
-              </a:rPr>
-              <a:t>de las personas no respondió a nada en nueve meses</a:t>
-            </a:r>
-            <a:endParaRPr lang="en-US" sz="1200" dirty="0"/>
-          </a:p>
-        </p:txBody>
-      </p:sp>
-      <p:sp>
-        <p:nvSpPr>
-          <p:cNvPr id="6" name="Shape 4"/>
-          <p:cNvSpPr/>
-          <p:nvPr/>
-        </p:nvSpPr>
-        <p:spPr>
-          <a:xfrm>
-            <a:off x="4331958" y="1161358"/>
-            <a:ext cx="3527628" cy="1398573"/>
-          </a:xfrm>
-          <a:prstGeom prst="rect">
-            <a:avLst/>
-          </a:prstGeom>
-          <a:solidFill>
-            <a:srgbClr val="F4F6F9"/>
-          </a:solidFill>
-          <a:ln/>
-        </p:spPr>
-      </p:sp>
-      <p:sp>
-        <p:nvSpPr>
-          <p:cNvPr id="7" name="Text 5"/>
-          <p:cNvSpPr txBox="1"/>
-          <p:nvPr/>
-        </p:nvSpPr>
-        <p:spPr>
-          <a:xfrm>
-            <a:off x="4514767" y="1356374"/>
-            <a:ext cx="3275158" cy="512107"/>
-          </a:xfrm>
-          <a:prstGeom prst="rect">
-            <a:avLst/>
-          </a:prstGeom>
-          <a:noFill/>
-          <a:ln/>
-        </p:spPr>
-        <p:txBody>
-          <a:bodyPr wrap="square" lIns="0" tIns="0" rIns="0" bIns="0" rtlCol="0" anchor="t"/>
-          <a:lstStyle/>
-          <a:p>
-            <a:pPr algn="l" indent="0" marL="0">
-              <a:lnSpc>
-                <a:spcPct val="83000"/>
-              </a:lnSpc>
-              <a:buNone/>
-            </a:pPr>
-            <a:r>
-              <a:rPr lang="en-US" sz="4030" b="1" spc="-80" kern="0" dirty="0">
-                <a:solidFill>
-                  <a:srgbClr val="0B1220"/>
-                </a:solidFill>
-                <a:latin typeface="Inter" pitchFamily="34" charset="0"/>
-                <a:ea typeface="Inter" pitchFamily="34" charset="-122"/>
-                <a:cs typeface="Inter" pitchFamily="34" charset="-120"/>
-              </a:rPr>
-              <a:t>2.3 M</a:t>
-            </a:r>
-            <a:endParaRPr lang="en-US" sz="4030" dirty="0"/>
-          </a:p>
-        </p:txBody>
-      </p:sp>
-      <p:sp>
-        <p:nvSpPr>
-          <p:cNvPr id="8" name="Text 6"/>
-          <p:cNvSpPr txBox="1"/>
-          <p:nvPr/>
-        </p:nvSpPr>
-        <p:spPr>
-          <a:xfrm>
-            <a:off x="4514767" y="1953782"/>
-            <a:ext cx="3275158" cy="411132"/>
-          </a:xfrm>
-          <a:prstGeom prst="rect">
-            <a:avLst/>
-          </a:prstGeom>
-          <a:noFill/>
-          <a:ln/>
-        </p:spPr>
-        <p:txBody>
-          <a:bodyPr wrap="square" lIns="0" tIns="0" rIns="0" bIns="0" rtlCol="0" anchor="t"/>
-          <a:lstStyle/>
-          <a:p>
-            <a:pPr algn="l" indent="0" marL="0">
-              <a:lnSpc>
-                <a:spcPct val="112000"/>
-              </a:lnSpc>
-              <a:buNone/>
-            </a:pPr>
-            <a:r>
-              <a:rPr lang="en-US" sz="1200" dirty="0">
-                <a:solidFill>
-                  <a:srgbClr val="0B1220"/>
-                </a:solidFill>
-                <a:latin typeface="Inter" pitchFamily="34" charset="0"/>
-                <a:ea typeface="Inter" pitchFamily="34" charset="-122"/>
-                <a:cs typeface="Inter" pitchFamily="34" charset="-120"/>
-              </a:rPr>
-              <a:t>personas al mes con tres o más campañas el mismo día</a:t>
-            </a:r>
-            <a:endParaRPr lang="en-US" sz="1200" dirty="0"/>
-          </a:p>
-        </p:txBody>
-      </p:sp>
-      <p:sp>
-        <p:nvSpPr>
-          <p:cNvPr id="9" name="Shape 7"/>
-          <p:cNvSpPr/>
-          <p:nvPr/>
-        </p:nvSpPr>
-        <p:spPr>
-          <a:xfrm>
-            <a:off x="8152111" y="1161358"/>
-            <a:ext cx="3527477" cy="1398573"/>
-          </a:xfrm>
-          <a:prstGeom prst="rect">
-            <a:avLst/>
-          </a:prstGeom>
-          <a:solidFill>
-            <a:srgbClr val="E8EEFC"/>
-          </a:solidFill>
-          <a:ln/>
-        </p:spPr>
-      </p:sp>
-      <p:sp>
-        <p:nvSpPr>
-          <p:cNvPr id="10" name="Text 8"/>
-          <p:cNvSpPr txBox="1"/>
-          <p:nvPr/>
-        </p:nvSpPr>
-        <p:spPr>
-          <a:xfrm>
-            <a:off x="8334920" y="1356374"/>
-            <a:ext cx="3275003" cy="512107"/>
-          </a:xfrm>
-          <a:prstGeom prst="rect">
-            <a:avLst/>
-          </a:prstGeom>
-          <a:noFill/>
-          <a:ln/>
-        </p:spPr>
-        <p:txBody>
-          <a:bodyPr wrap="square" lIns="0" tIns="0" rIns="0" bIns="0" rtlCol="0" anchor="t"/>
-          <a:lstStyle/>
-          <a:p>
-            <a:pPr algn="l" indent="0" marL="0">
-              <a:lnSpc>
-                <a:spcPct val="83000"/>
-              </a:lnSpc>
-              <a:buNone/>
-            </a:pPr>
-            <a:r>
-              <a:rPr lang="en-US" sz="4030" b="1" spc="-80" kern="0" dirty="0">
-                <a:solidFill>
-                  <a:srgbClr val="1F4FD8"/>
-                </a:solidFill>
-                <a:latin typeface="Inter" pitchFamily="34" charset="0"/>
-                <a:ea typeface="Inter" pitchFamily="34" charset="-122"/>
-                <a:cs typeface="Inter" pitchFamily="34" charset="-120"/>
-              </a:rPr>
-              <a:t>1 de 3,228</a:t>
-            </a:r>
-            <a:endParaRPr lang="en-US" sz="4030" dirty="0"/>
-          </a:p>
-        </p:txBody>
-      </p:sp>
-      <p:sp>
-        <p:nvSpPr>
-          <p:cNvPr id="11" name="Text 9"/>
-          <p:cNvSpPr txBox="1"/>
-          <p:nvPr/>
-        </p:nvSpPr>
-        <p:spPr>
-          <a:xfrm>
-            <a:off x="8334920" y="1953782"/>
-            <a:ext cx="3275003" cy="205566"/>
-          </a:xfrm>
-          <a:prstGeom prst="rect">
-            <a:avLst/>
-          </a:prstGeom>
-          <a:noFill/>
-          <a:ln/>
-        </p:spPr>
-        <p:txBody>
-          <a:bodyPr wrap="square" lIns="0" tIns="0" rIns="0" bIns="0" rtlCol="0" anchor="t"/>
-          <a:lstStyle/>
-          <a:p>
-            <a:pPr algn="l" indent="0" marL="0">
-              <a:lnSpc>
-                <a:spcPct val="112000"/>
-              </a:lnSpc>
-              <a:buNone/>
-            </a:pPr>
-            <a:r>
-              <a:rPr lang="en-US" sz="1200" dirty="0">
-                <a:solidFill>
-                  <a:srgbClr val="0B1220"/>
-                </a:solidFill>
-                <a:latin typeface="Inter" pitchFamily="34" charset="0"/>
-                <a:ea typeface="Inter" pitchFamily="34" charset="-122"/>
-                <a:cs typeface="Inter" pitchFamily="34" charset="-120"/>
-              </a:rPr>
-              <a:t>Canvas tiene un grupo de control real</a:t>
-            </a:r>
-            <a:endParaRPr lang="en-US" sz="1200" dirty="0"/>
-          </a:p>
-        </p:txBody>
-      </p:sp>
-      <p:sp>
-        <p:nvSpPr>
-          <p:cNvPr id="12" name="Shape 10"/>
-          <p:cNvSpPr/>
-          <p:nvPr/>
-        </p:nvSpPr>
-        <p:spPr>
-          <a:xfrm>
-            <a:off x="511956" y="2784184"/>
-            <a:ext cx="3527477" cy="0"/>
+            <a:off x="511956" y="835376"/>
+            <a:ext cx="11167783" cy="0"/>
           </a:xfrm>
           <a:prstGeom prst="line">
             <a:avLst/>
@@ -4590,135 +4368,14 @@
       </p:sp>
       <p:sp>
         <p:nvSpPr>
-          <p:cNvPr id="13" name="Shape 11"/>
+          <p:cNvPr id="4" name="Shape 2"/>
           <p:cNvSpPr/>
           <p:nvPr/>
         </p:nvSpPr>
         <p:spPr>
           <a:xfrm>
-            <a:off x="511956" y="2922987"/>
-            <a:ext cx="231639" cy="231639"/>
-          </a:xfrm>
-          <a:prstGeom prst="ellipse">
-            <a:avLst/>
-          </a:prstGeom>
-          <a:solidFill>
-            <a:srgbClr val="E8EEFC"/>
-          </a:solidFill>
-          <a:ln/>
-        </p:spPr>
-      </p:sp>
-      <p:sp>
-        <p:nvSpPr>
-          <p:cNvPr id="14" name="Text 12"/>
-          <p:cNvSpPr txBox="1"/>
-          <p:nvPr/>
-        </p:nvSpPr>
-        <p:spPr>
-          <a:xfrm>
-            <a:off x="511956" y="2922987"/>
-            <a:ext cx="256876" cy="231639"/>
-          </a:xfrm>
-          <a:prstGeom prst="rect">
-            <a:avLst/>
-          </a:prstGeom>
-          <a:noFill/>
-          <a:ln/>
-        </p:spPr>
-        <p:txBody>
-          <a:bodyPr wrap="square" lIns="0" tIns="0" rIns="0" bIns="0" rtlCol="0" anchor="ctr"/>
-          <a:lstStyle/>
-          <a:p>
-            <a:pPr algn="ctr" indent="0" marL="0">
-              <a:lnSpc>
-                <a:spcPct val="112000"/>
-              </a:lnSpc>
-              <a:buNone/>
-            </a:pPr>
-            <a:r>
-              <a:rPr lang="en-US" sz="960" b="1" dirty="0">
-                <a:solidFill>
-                  <a:srgbClr val="1F4FD8"/>
-                </a:solidFill>
-                <a:latin typeface="Inter" pitchFamily="34" charset="0"/>
-                <a:ea typeface="Inter" pitchFamily="34" charset="-122"/>
-                <a:cs typeface="Inter" pitchFamily="34" charset="-120"/>
-              </a:rPr>
-              <a:t>1</a:t>
-            </a:r>
-            <a:endParaRPr lang="en-US" sz="960" dirty="0"/>
-          </a:p>
-        </p:txBody>
-      </p:sp>
-      <p:sp>
-        <p:nvSpPr>
-          <p:cNvPr id="15" name="Text 13"/>
-          <p:cNvSpPr txBox="1"/>
-          <p:nvPr/>
-        </p:nvSpPr>
-        <p:spPr>
-          <a:xfrm>
-            <a:off x="853310" y="2922987"/>
-            <a:ext cx="3299995" cy="1109213"/>
-          </a:xfrm>
-          <a:prstGeom prst="rect">
-            <a:avLst/>
-          </a:prstGeom>
-          <a:noFill/>
-          <a:ln/>
-        </p:spPr>
-        <p:txBody>
-          <a:bodyPr wrap="square" lIns="0" tIns="0" rIns="0" bIns="0" rtlCol="0" anchor="t"/>
-          <a:lstStyle/>
-          <a:p>
-            <a:pPr algn="l" indent="0" marL="0">
-              <a:lnSpc>
-                <a:spcPct val="116000"/>
-              </a:lnSpc>
-              <a:buNone/>
-            </a:pPr>
-            <a:r>
-              <a:rPr lang="en-US" sz="1250" b="1" dirty="0">
-                <a:solidFill>
-                  <a:srgbClr val="0B1220"/>
-                </a:solidFill>
-                <a:latin typeface="Inter" pitchFamily="34" charset="0"/>
-                <a:ea typeface="Inter" pitchFamily="34" charset="-122"/>
-                <a:cs typeface="Inter" pitchFamily="34" charset="-120"/>
-              </a:rPr>
-              <a:t>Escribimos por lo que queremos vender.</a:t>
-            </a:r>
-            <a:pPr algn="l" indent="0" marL="0">
-              <a:lnSpc>
-                <a:spcPct val="116000"/>
-              </a:lnSpc>
-              <a:buNone/>
-            </a:pPr>
-            <a:r>
-              <a:rPr lang="en-US" sz="1250" dirty="0">
-                <a:solidFill>
-                  <a:srgbClr val="0B1220"/>
-                </a:solidFill>
-                <a:latin typeface="Inter" pitchFamily="34" charset="0"/>
-                <a:ea typeface="Inter" pitchFamily="34" charset="-122"/>
-                <a:cs typeface="Inter" pitchFamily="34" charset="-120"/>
-              </a:rPr>
-              <a:t> Las promociones salen a listas por etapa, no por lo que la persona hizo, y le seguimos escribiendo a quien no responde.</a:t>
-            </a:r>
-            <a:endParaRPr lang="en-US" sz="1250" dirty="0"/>
-          </a:p>
-        </p:txBody>
-      </p:sp>
-      <p:sp>
-        <p:nvSpPr>
-          <p:cNvPr id="16" name="Shape 14"/>
-          <p:cNvSpPr/>
-          <p:nvPr/>
-        </p:nvSpPr>
-        <p:spPr>
-          <a:xfrm>
-            <a:off x="4331958" y="2784184"/>
-            <a:ext cx="3527628" cy="0"/>
+            <a:off x="511956" y="1467446"/>
+            <a:ext cx="11167783" cy="0"/>
           </a:xfrm>
           <a:prstGeom prst="line">
             <a:avLst/>
@@ -4734,16 +4391,1460 @@
       </p:sp>
       <p:sp>
         <p:nvSpPr>
-          <p:cNvPr id="17" name="Shape 15"/>
+          <p:cNvPr id="5" name="Text 3"/>
+          <p:cNvSpPr txBox="1"/>
+          <p:nvPr/>
+        </p:nvSpPr>
+        <p:spPr>
+          <a:xfrm>
+            <a:off x="511956" y="925499"/>
+            <a:ext cx="3718649" cy="129760"/>
+          </a:xfrm>
+          <a:prstGeom prst="rect">
+            <a:avLst/>
+          </a:prstGeom>
+          <a:noFill/>
+          <a:ln/>
+        </p:spPr>
+        <p:txBody>
+          <a:bodyPr wrap="square" lIns="0" tIns="0" rIns="0" bIns="0" rtlCol="0" anchor="t"/>
+          <a:lstStyle/>
+          <a:p>
+            <a:pPr algn="l" indent="0" marL="0">
+              <a:lnSpc>
+                <a:spcPct val="107000"/>
+              </a:lnSpc>
+              <a:buNone/>
+            </a:pPr>
+            <a:r>
+              <a:rPr lang="en-US" sz="790" b="1" spc="80" kern="0" dirty="0">
+                <a:solidFill>
+                  <a:srgbClr val="6B7484"/>
+                </a:solidFill>
+                <a:latin typeface="Inter" pitchFamily="34" charset="0"/>
+                <a:ea typeface="Inter" pitchFamily="34" charset="-122"/>
+                <a:cs typeface="Inter" pitchFamily="34" charset="-120"/>
+              </a:rPr>
+              <a:t>QUÉ SE MANDA</a:t>
+            </a:r>
+            <a:endParaRPr lang="en-US" sz="790" dirty="0"/>
+          </a:p>
+        </p:txBody>
+      </p:sp>
+      <p:sp>
+        <p:nvSpPr>
+          <p:cNvPr id="6" name="Text 4"/>
+          <p:cNvSpPr txBox="1"/>
+          <p:nvPr/>
+        </p:nvSpPr>
+        <p:spPr>
+          <a:xfrm>
+            <a:off x="511956" y="1079523"/>
+            <a:ext cx="3039830" cy="293580"/>
+          </a:xfrm>
+          <a:prstGeom prst="rect">
+            <a:avLst/>
+          </a:prstGeom>
+          <a:noFill/>
+          <a:ln/>
+        </p:spPr>
+        <p:txBody>
+          <a:bodyPr wrap="square" lIns="0" tIns="0" rIns="0" bIns="0" rtlCol="0" anchor="t"/>
+          <a:lstStyle/>
+          <a:p>
+            <a:pPr algn="l" indent="0" marL="0">
+              <a:lnSpc>
+                <a:spcPct val="107000"/>
+              </a:lnSpc>
+              <a:buNone/>
+            </a:pPr>
+            <a:r>
+              <a:rPr lang="en-US" sz="900" dirty="0">
+                <a:solidFill>
+                  <a:srgbClr val="3B4556"/>
+                </a:solidFill>
+                <a:latin typeface="Inter" pitchFamily="34" charset="0"/>
+                <a:ea typeface="Inter" pitchFamily="34" charset="-122"/>
+                <a:cs typeface="Inter" pitchFamily="34" charset="-120"/>
+              </a:rPr>
+              <a:t>Todo lo que vive en Braze: campañas, Canvas, listas y configuración.</a:t>
+            </a:r>
+            <a:endParaRPr lang="en-US" sz="900" dirty="0"/>
+          </a:p>
+        </p:txBody>
+      </p:sp>
+      <p:sp>
+        <p:nvSpPr>
+          <p:cNvPr id="7" name="Text 5"/>
+          <p:cNvSpPr txBox="1"/>
+          <p:nvPr/>
+        </p:nvSpPr>
+        <p:spPr>
+          <a:xfrm>
+            <a:off x="4299556" y="925499"/>
+            <a:ext cx="3718649" cy="129760"/>
+          </a:xfrm>
+          <a:prstGeom prst="rect">
+            <a:avLst/>
+          </a:prstGeom>
+          <a:noFill/>
+          <a:ln/>
+        </p:spPr>
+        <p:txBody>
+          <a:bodyPr wrap="square" lIns="0" tIns="0" rIns="0" bIns="0" rtlCol="0" anchor="t"/>
+          <a:lstStyle/>
+          <a:p>
+            <a:pPr algn="l" indent="0" marL="0">
+              <a:lnSpc>
+                <a:spcPct val="107000"/>
+              </a:lnSpc>
+              <a:buNone/>
+            </a:pPr>
+            <a:r>
+              <a:rPr lang="en-US" sz="790" b="1" spc="80" kern="0" dirty="0">
+                <a:solidFill>
+                  <a:srgbClr val="6B7484"/>
+                </a:solidFill>
+                <a:latin typeface="Inter" pitchFamily="34" charset="0"/>
+                <a:ea typeface="Inter" pitchFamily="34" charset="-122"/>
+                <a:cs typeface="Inter" pitchFamily="34" charset="-120"/>
+              </a:rPr>
+              <a:t>QUIÉN</a:t>
+            </a:r>
+            <a:endParaRPr lang="en-US" sz="790" dirty="0"/>
+          </a:p>
+        </p:txBody>
+      </p:sp>
+      <p:sp>
+        <p:nvSpPr>
+          <p:cNvPr id="8" name="Text 6"/>
+          <p:cNvSpPr txBox="1"/>
+          <p:nvPr/>
+        </p:nvSpPr>
+        <p:spPr>
+          <a:xfrm>
+            <a:off x="4299556" y="1079523"/>
+            <a:ext cx="3256841" cy="144680"/>
+          </a:xfrm>
+          <a:prstGeom prst="rect">
+            <a:avLst/>
+          </a:prstGeom>
+          <a:noFill/>
+          <a:ln/>
+        </p:spPr>
+        <p:txBody>
+          <a:bodyPr wrap="square" lIns="0" tIns="0" rIns="0" bIns="0" rtlCol="0" anchor="t"/>
+          <a:lstStyle/>
+          <a:p>
+            <a:pPr algn="l" indent="0" marL="0">
+              <a:lnSpc>
+                <a:spcPct val="107000"/>
+              </a:lnSpc>
+              <a:buNone/>
+            </a:pPr>
+            <a:r>
+              <a:rPr lang="en-US" sz="900" dirty="0">
+                <a:solidFill>
+                  <a:srgbClr val="3B4556"/>
+                </a:solidFill>
+                <a:latin typeface="Inter" pitchFamily="34" charset="0"/>
+                <a:ea typeface="Inter" pitchFamily="34" charset="-122"/>
+                <a:cs typeface="Inter" pitchFamily="34" charset="-120"/>
+              </a:rPr>
+              <a:t>Todos los equipos; nadie es dueño de la cuenta completa.</a:t>
+            </a:r>
+            <a:endParaRPr lang="en-US" sz="900" dirty="0"/>
+          </a:p>
+        </p:txBody>
+      </p:sp>
+      <p:sp>
+        <p:nvSpPr>
+          <p:cNvPr id="9" name="Text 7"/>
+          <p:cNvSpPr txBox="1"/>
+          <p:nvPr/>
+        </p:nvSpPr>
+        <p:spPr>
+          <a:xfrm>
+            <a:off x="8087156" y="925499"/>
+            <a:ext cx="3718649" cy="129760"/>
+          </a:xfrm>
+          <a:prstGeom prst="rect">
+            <a:avLst/>
+          </a:prstGeom>
+          <a:noFill/>
+          <a:ln/>
+        </p:spPr>
+        <p:txBody>
+          <a:bodyPr wrap="square" lIns="0" tIns="0" rIns="0" bIns="0" rtlCol="0" anchor="t"/>
+          <a:lstStyle/>
+          <a:p>
+            <a:pPr algn="l" indent="0" marL="0">
+              <a:lnSpc>
+                <a:spcPct val="107000"/>
+              </a:lnSpc>
+              <a:buNone/>
+            </a:pPr>
+            <a:r>
+              <a:rPr lang="en-US" sz="790" b="1" spc="80" kern="0" dirty="0">
+                <a:solidFill>
+                  <a:srgbClr val="6B7484"/>
+                </a:solidFill>
+                <a:latin typeface="Inter" pitchFamily="34" charset="0"/>
+                <a:ea typeface="Inter" pitchFamily="34" charset="-122"/>
+                <a:cs typeface="Inter" pitchFamily="34" charset="-120"/>
+              </a:rPr>
+              <a:t>A QUIÉN</a:t>
+            </a:r>
+            <a:endParaRPr lang="en-US" sz="790" dirty="0"/>
+          </a:p>
+        </p:txBody>
+      </p:sp>
+      <p:sp>
+        <p:nvSpPr>
+          <p:cNvPr id="10" name="Text 8"/>
+          <p:cNvSpPr txBox="1"/>
+          <p:nvPr/>
+        </p:nvSpPr>
+        <p:spPr>
+          <a:xfrm>
+            <a:off x="8087156" y="1079523"/>
+            <a:ext cx="2931791" cy="144680"/>
+          </a:xfrm>
+          <a:prstGeom prst="rect">
+            <a:avLst/>
+          </a:prstGeom>
+          <a:noFill/>
+          <a:ln/>
+        </p:spPr>
+        <p:txBody>
+          <a:bodyPr wrap="square" lIns="0" tIns="0" rIns="0" bIns="0" rtlCol="0" anchor="t"/>
+          <a:lstStyle/>
+          <a:p>
+            <a:pPr algn="l" indent="0" marL="0">
+              <a:lnSpc>
+                <a:spcPct val="107000"/>
+              </a:lnSpc>
+              <a:buNone/>
+            </a:pPr>
+            <a:r>
+              <a:rPr lang="en-US" sz="900" dirty="0">
+                <a:solidFill>
+                  <a:srgbClr val="3B4556"/>
+                </a:solidFill>
+                <a:latin typeface="Inter" pitchFamily="34" charset="0"/>
+                <a:ea typeface="Inter" pitchFamily="34" charset="-122"/>
+                <a:cs typeface="Inter" pitchFamily="34" charset="-120"/>
+              </a:rPr>
+              <a:t>Toda la base, incluidos bloqueados y dados de baja.</a:t>
+            </a:r>
+            <a:endParaRPr lang="en-US" sz="900" dirty="0"/>
+          </a:p>
+        </p:txBody>
+      </p:sp>
+      <p:sp>
+        <p:nvSpPr>
+          <p:cNvPr id="11" name="Shape 9"/>
           <p:cNvSpPr/>
           <p:nvPr/>
         </p:nvSpPr>
         <p:spPr>
           <a:xfrm>
-            <a:off x="4331958" y="2922987"/>
-            <a:ext cx="231639" cy="231639"/>
-          </a:xfrm>
-          <a:prstGeom prst="ellipse">
+            <a:off x="511956" y="1591630"/>
+            <a:ext cx="2609061" cy="0"/>
+          </a:xfrm>
+          <a:prstGeom prst="line">
+            <a:avLst/>
+          </a:prstGeom>
+          <a:noFill/>
+          <a:ln w="19291">
+            <a:solidFill>
+              <a:srgbClr val="0B1220"/>
+            </a:solidFill>
+            <a:prstDash val="solid"/>
+          </a:ln>
+        </p:spPr>
+      </p:sp>
+      <p:sp>
+        <p:nvSpPr>
+          <p:cNvPr id="12" name="Text 10"/>
+          <p:cNvSpPr txBox="1"/>
+          <p:nvPr/>
+        </p:nvSpPr>
+        <p:spPr>
+          <a:xfrm>
+            <a:off x="511956" y="1710991"/>
+            <a:ext cx="2705621" cy="134884"/>
+          </a:xfrm>
+          <a:prstGeom prst="rect">
+            <a:avLst/>
+          </a:prstGeom>
+          <a:noFill/>
+          <a:ln/>
+        </p:spPr>
+        <p:txBody>
+          <a:bodyPr wrap="square" lIns="0" tIns="0" rIns="0" bIns="0" rtlCol="0" anchor="t"/>
+          <a:lstStyle/>
+          <a:p>
+            <a:pPr algn="l" indent="0" marL="0">
+              <a:lnSpc>
+                <a:spcPct val="112000"/>
+              </a:lnSpc>
+              <a:buNone/>
+            </a:pPr>
+            <a:r>
+              <a:rPr lang="en-US" sz="790" b="1" spc="80" kern="0" dirty="0">
+                <a:solidFill>
+                  <a:srgbClr val="6B7484"/>
+                </a:solidFill>
+                <a:latin typeface="Inter" pitchFamily="34" charset="0"/>
+                <a:ea typeface="Inter" pitchFamily="34" charset="-122"/>
+                <a:cs typeface="Inter" pitchFamily="34" charset="-120"/>
+              </a:rPr>
+              <a:t>ORDEN</a:t>
+            </a:r>
+            <a:endParaRPr lang="en-US" sz="790" dirty="0"/>
+          </a:p>
+        </p:txBody>
+      </p:sp>
+      <p:sp>
+        <p:nvSpPr>
+          <p:cNvPr id="13" name="Text 11"/>
+          <p:cNvSpPr txBox="1"/>
+          <p:nvPr/>
+        </p:nvSpPr>
+        <p:spPr>
+          <a:xfrm>
+            <a:off x="511956" y="1900733"/>
+            <a:ext cx="2705621" cy="390184"/>
+          </a:xfrm>
+          <a:prstGeom prst="rect">
+            <a:avLst/>
+          </a:prstGeom>
+          <a:noFill/>
+          <a:ln/>
+        </p:spPr>
+        <p:txBody>
+          <a:bodyPr wrap="square" lIns="0" tIns="0" rIns="0" bIns="0" rtlCol="0" anchor="t"/>
+          <a:lstStyle/>
+          <a:p>
+            <a:pPr algn="l" indent="0" marL="0">
+              <a:lnSpc>
+                <a:spcPct val="83000"/>
+              </a:lnSpc>
+              <a:buNone/>
+            </a:pPr>
+            <a:r>
+              <a:rPr lang="en-US" sz="3070" b="1" spc="-60" kern="0" dirty="0">
+                <a:solidFill>
+                  <a:srgbClr val="0B1220"/>
+                </a:solidFill>
+                <a:latin typeface="Inter" pitchFamily="34" charset="0"/>
+                <a:ea typeface="Inter" pitchFamily="34" charset="-122"/>
+                <a:cs typeface="Inter" pitchFamily="34" charset="-120"/>
+              </a:rPr>
+              <a:t>6,144</a:t>
+            </a:r>
+            <a:endParaRPr lang="en-US" sz="3070" dirty="0"/>
+          </a:p>
+        </p:txBody>
+      </p:sp>
+      <p:sp>
+        <p:nvSpPr>
+          <p:cNvPr id="14" name="Text 12"/>
+          <p:cNvSpPr txBox="1"/>
+          <p:nvPr/>
+        </p:nvSpPr>
+        <p:spPr>
+          <a:xfrm>
+            <a:off x="511956" y="2345774"/>
+            <a:ext cx="2705621" cy="378278"/>
+          </a:xfrm>
+          <a:prstGeom prst="rect">
+            <a:avLst/>
+          </a:prstGeom>
+          <a:noFill/>
+          <a:ln/>
+        </p:spPr>
+        <p:txBody>
+          <a:bodyPr wrap="square" lIns="0" tIns="0" rIns="0" bIns="0" rtlCol="0" anchor="t"/>
+          <a:lstStyle/>
+          <a:p>
+            <a:pPr algn="l" indent="0" marL="0">
+              <a:lnSpc>
+                <a:spcPct val="112000"/>
+              </a:lnSpc>
+              <a:buNone/>
+            </a:pPr>
+            <a:r>
+              <a:rPr lang="en-US" sz="1100" dirty="0">
+                <a:solidFill>
+                  <a:srgbClr val="3B4556"/>
+                </a:solidFill>
+                <a:latin typeface="Inter" pitchFamily="34" charset="0"/>
+                <a:ea typeface="Inter" pitchFamily="34" charset="-122"/>
+                <a:cs typeface="Inter" pitchFamily="34" charset="-120"/>
+              </a:rPr>
+              <a:t>comunicaciones guardadas; en septiembre solo 341 mandaron algo</a:t>
+            </a:r>
+            <a:endParaRPr lang="en-US" sz="1100" dirty="0"/>
+          </a:p>
+        </p:txBody>
+      </p:sp>
+      <p:sp>
+        <p:nvSpPr>
+          <p:cNvPr id="15" name="Shape 13"/>
+          <p:cNvSpPr/>
+          <p:nvPr/>
+        </p:nvSpPr>
+        <p:spPr>
+          <a:xfrm>
+            <a:off x="3364713" y="1591630"/>
+            <a:ext cx="2609212" cy="0"/>
+          </a:xfrm>
+          <a:prstGeom prst="line">
+            <a:avLst/>
+          </a:prstGeom>
+          <a:noFill/>
+          <a:ln w="19291">
+            <a:solidFill>
+              <a:srgbClr val="0B1220"/>
+            </a:solidFill>
+            <a:prstDash val="solid"/>
+          </a:ln>
+        </p:spPr>
+      </p:sp>
+      <p:sp>
+        <p:nvSpPr>
+          <p:cNvPr id="16" name="Text 14"/>
+          <p:cNvSpPr txBox="1"/>
+          <p:nvPr/>
+        </p:nvSpPr>
+        <p:spPr>
+          <a:xfrm>
+            <a:off x="3364713" y="1710991"/>
+            <a:ext cx="2705776" cy="134884"/>
+          </a:xfrm>
+          <a:prstGeom prst="rect">
+            <a:avLst/>
+          </a:prstGeom>
+          <a:noFill/>
+          <a:ln/>
+        </p:spPr>
+        <p:txBody>
+          <a:bodyPr wrap="square" lIns="0" tIns="0" rIns="0" bIns="0" rtlCol="0" anchor="t"/>
+          <a:lstStyle/>
+          <a:p>
+            <a:pPr algn="l" indent="0" marL="0">
+              <a:lnSpc>
+                <a:spcPct val="112000"/>
+              </a:lnSpc>
+              <a:buNone/>
+            </a:pPr>
+            <a:r>
+              <a:rPr lang="en-US" sz="790" b="1" spc="80" kern="0" dirty="0">
+                <a:solidFill>
+                  <a:srgbClr val="6B7484"/>
+                </a:solidFill>
+                <a:latin typeface="Inter" pitchFamily="34" charset="0"/>
+                <a:ea typeface="Inter" pitchFamily="34" charset="-122"/>
+                <a:cs typeface="Inter" pitchFamily="34" charset="-120"/>
+              </a:rPr>
+              <a:t>ORDEN</a:t>
+            </a:r>
+            <a:endParaRPr lang="en-US" sz="790" dirty="0"/>
+          </a:p>
+        </p:txBody>
+      </p:sp>
+      <p:sp>
+        <p:nvSpPr>
+          <p:cNvPr id="17" name="Text 15"/>
+          <p:cNvSpPr txBox="1"/>
+          <p:nvPr/>
+        </p:nvSpPr>
+        <p:spPr>
+          <a:xfrm>
+            <a:off x="3364713" y="1900733"/>
+            <a:ext cx="2705776" cy="390184"/>
+          </a:xfrm>
+          <a:prstGeom prst="rect">
+            <a:avLst/>
+          </a:prstGeom>
+          <a:noFill/>
+          <a:ln/>
+        </p:spPr>
+        <p:txBody>
+          <a:bodyPr wrap="square" lIns="0" tIns="0" rIns="0" bIns="0" rtlCol="0" anchor="t"/>
+          <a:lstStyle/>
+          <a:p>
+            <a:pPr algn="l" indent="0" marL="0">
+              <a:lnSpc>
+                <a:spcPct val="83000"/>
+              </a:lnSpc>
+              <a:buNone/>
+            </a:pPr>
+            <a:r>
+              <a:rPr lang="en-US" sz="3070" b="1" spc="-60" kern="0" dirty="0">
+                <a:solidFill>
+                  <a:srgbClr val="0B1220"/>
+                </a:solidFill>
+                <a:latin typeface="Inter" pitchFamily="34" charset="0"/>
+                <a:ea typeface="Inter" pitchFamily="34" charset="-122"/>
+                <a:cs typeface="Inter" pitchFamily="34" charset="-120"/>
+              </a:rPr>
+              <a:t>229</a:t>
+            </a:r>
+            <a:endParaRPr lang="en-US" sz="3070" dirty="0"/>
+          </a:p>
+        </p:txBody>
+      </p:sp>
+      <p:sp>
+        <p:nvSpPr>
+          <p:cNvPr id="18" name="Text 16"/>
+          <p:cNvSpPr txBox="1"/>
+          <p:nvPr/>
+        </p:nvSpPr>
+        <p:spPr>
+          <a:xfrm>
+            <a:off x="3364713" y="2345774"/>
+            <a:ext cx="2705776" cy="378278"/>
+          </a:xfrm>
+          <a:prstGeom prst="rect">
+            <a:avLst/>
+          </a:prstGeom>
+          <a:noFill/>
+          <a:ln/>
+        </p:spPr>
+        <p:txBody>
+          <a:bodyPr wrap="square" lIns="0" tIns="0" rIns="0" bIns="0" rtlCol="0" anchor="t"/>
+          <a:lstStyle/>
+          <a:p>
+            <a:pPr algn="l" indent="0" marL="0">
+              <a:lnSpc>
+                <a:spcPct val="112000"/>
+              </a:lnSpc>
+              <a:buNone/>
+            </a:pPr>
+            <a:r>
+              <a:rPr lang="en-US" sz="1100" dirty="0">
+                <a:solidFill>
+                  <a:srgbClr val="3B4556"/>
+                </a:solidFill>
+                <a:latin typeface="Inter" pitchFamily="34" charset="0"/>
+                <a:ea typeface="Inter" pitchFamily="34" charset="-122"/>
+                <a:cs typeface="Inter" pitchFamily="34" charset="-120"/>
+              </a:rPr>
+              <a:t>marcadas como archivadas siguieron enviando en septiembre</a:t>
+            </a:r>
+            <a:endParaRPr lang="en-US" sz="1100" dirty="0"/>
+          </a:p>
+        </p:txBody>
+      </p:sp>
+      <p:sp>
+        <p:nvSpPr>
+          <p:cNvPr id="19" name="Shape 17"/>
+          <p:cNvSpPr/>
+          <p:nvPr/>
+        </p:nvSpPr>
+        <p:spPr>
+          <a:xfrm>
+            <a:off x="6217620" y="1591630"/>
+            <a:ext cx="2609212" cy="0"/>
+          </a:xfrm>
+          <a:prstGeom prst="line">
+            <a:avLst/>
+          </a:prstGeom>
+          <a:noFill/>
+          <a:ln w="19291">
+            <a:solidFill>
+              <a:srgbClr val="0B1220"/>
+            </a:solidFill>
+            <a:prstDash val="solid"/>
+          </a:ln>
+        </p:spPr>
+      </p:sp>
+      <p:sp>
+        <p:nvSpPr>
+          <p:cNvPr id="20" name="Text 18"/>
+          <p:cNvSpPr txBox="1"/>
+          <p:nvPr/>
+        </p:nvSpPr>
+        <p:spPr>
+          <a:xfrm>
+            <a:off x="6217620" y="1710991"/>
+            <a:ext cx="2705776" cy="134884"/>
+          </a:xfrm>
+          <a:prstGeom prst="rect">
+            <a:avLst/>
+          </a:prstGeom>
+          <a:noFill/>
+          <a:ln/>
+        </p:spPr>
+        <p:txBody>
+          <a:bodyPr wrap="square" lIns="0" tIns="0" rIns="0" bIns="0" rtlCol="0" anchor="t"/>
+          <a:lstStyle/>
+          <a:p>
+            <a:pPr algn="l" indent="0" marL="0">
+              <a:lnSpc>
+                <a:spcPct val="112000"/>
+              </a:lnSpc>
+              <a:buNone/>
+            </a:pPr>
+            <a:r>
+              <a:rPr lang="en-US" sz="790" b="1" spc="80" kern="0" dirty="0">
+                <a:solidFill>
+                  <a:srgbClr val="6B7484"/>
+                </a:solidFill>
+                <a:latin typeface="Inter" pitchFamily="34" charset="0"/>
+                <a:ea typeface="Inter" pitchFamily="34" charset="-122"/>
+                <a:cs typeface="Inter" pitchFamily="34" charset="-120"/>
+              </a:rPr>
+              <a:t>DUEÑO</a:t>
+            </a:r>
+            <a:endParaRPr lang="en-US" sz="790" dirty="0"/>
+          </a:p>
+        </p:txBody>
+      </p:sp>
+      <p:sp>
+        <p:nvSpPr>
+          <p:cNvPr id="21" name="Text 19"/>
+          <p:cNvSpPr txBox="1"/>
+          <p:nvPr/>
+        </p:nvSpPr>
+        <p:spPr>
+          <a:xfrm>
+            <a:off x="6217620" y="1900733"/>
+            <a:ext cx="2705776" cy="390184"/>
+          </a:xfrm>
+          <a:prstGeom prst="rect">
+            <a:avLst/>
+          </a:prstGeom>
+          <a:noFill/>
+          <a:ln/>
+        </p:spPr>
+        <p:txBody>
+          <a:bodyPr wrap="square" lIns="0" tIns="0" rIns="0" bIns="0" rtlCol="0" anchor="t"/>
+          <a:lstStyle/>
+          <a:p>
+            <a:pPr algn="l" indent="0" marL="0">
+              <a:lnSpc>
+                <a:spcPct val="83000"/>
+              </a:lnSpc>
+              <a:buNone/>
+            </a:pPr>
+            <a:r>
+              <a:rPr lang="en-US" sz="3070" b="1" spc="-60" kern="0" dirty="0">
+                <a:solidFill>
+                  <a:srgbClr val="0B1220"/>
+                </a:solidFill>
+                <a:latin typeface="Inter" pitchFamily="34" charset="0"/>
+                <a:ea typeface="Inter" pitchFamily="34" charset="-122"/>
+                <a:cs typeface="Inter" pitchFamily="34" charset="-120"/>
+              </a:rPr>
+              <a:t>748</a:t>
+            </a:r>
+            <a:endParaRPr lang="en-US" sz="3070" dirty="0"/>
+          </a:p>
+        </p:txBody>
+      </p:sp>
+      <p:sp>
+        <p:nvSpPr>
+          <p:cNvPr id="22" name="Text 20"/>
+          <p:cNvSpPr txBox="1"/>
+          <p:nvPr/>
+        </p:nvSpPr>
+        <p:spPr>
+          <a:xfrm>
+            <a:off x="6217620" y="2345774"/>
+            <a:ext cx="2705776" cy="567417"/>
+          </a:xfrm>
+          <a:prstGeom prst="rect">
+            <a:avLst/>
+          </a:prstGeom>
+          <a:noFill/>
+          <a:ln/>
+        </p:spPr>
+        <p:txBody>
+          <a:bodyPr wrap="square" lIns="0" tIns="0" rIns="0" bIns="0" rtlCol="0" anchor="t"/>
+          <a:lstStyle/>
+          <a:p>
+            <a:pPr algn="l" indent="0" marL="0">
+              <a:lnSpc>
+                <a:spcPct val="112000"/>
+              </a:lnSpc>
+              <a:buNone/>
+            </a:pPr>
+            <a:r>
+              <a:rPr lang="en-US" sz="1100" dirty="0">
+                <a:solidFill>
+                  <a:srgbClr val="3B4556"/>
+                </a:solidFill>
+                <a:latin typeface="Inter" pitchFamily="34" charset="0"/>
+                <a:ea typeface="Inter" pitchFamily="34" charset="-122"/>
+                <a:cs typeface="Inter" pitchFamily="34" charset="-120"/>
+              </a:rPr>
+              <a:t>comunicaciones sin equipo ni ticket; 210 de ellas mandaron 85 M mensajes en 2026</a:t>
+            </a:r>
+            <a:endParaRPr lang="en-US" sz="1100" dirty="0"/>
+          </a:p>
+        </p:txBody>
+      </p:sp>
+      <p:sp>
+        <p:nvSpPr>
+          <p:cNvPr id="23" name="Shape 21"/>
+          <p:cNvSpPr/>
+          <p:nvPr/>
+        </p:nvSpPr>
+        <p:spPr>
+          <a:xfrm>
+            <a:off x="9070527" y="1591630"/>
+            <a:ext cx="2609212" cy="0"/>
+          </a:xfrm>
+          <a:prstGeom prst="line">
+            <a:avLst/>
+          </a:prstGeom>
+          <a:noFill/>
+          <a:ln w="19291">
+            <a:solidFill>
+              <a:srgbClr val="0B1220"/>
+            </a:solidFill>
+            <a:prstDash val="solid"/>
+          </a:ln>
+        </p:spPr>
+      </p:sp>
+      <p:sp>
+        <p:nvSpPr>
+          <p:cNvPr id="24" name="Text 22"/>
+          <p:cNvSpPr txBox="1"/>
+          <p:nvPr/>
+        </p:nvSpPr>
+        <p:spPr>
+          <a:xfrm>
+            <a:off x="9070527" y="1710991"/>
+            <a:ext cx="2705776" cy="134884"/>
+          </a:xfrm>
+          <a:prstGeom prst="rect">
+            <a:avLst/>
+          </a:prstGeom>
+          <a:noFill/>
+          <a:ln/>
+        </p:spPr>
+        <p:txBody>
+          <a:bodyPr wrap="square" lIns="0" tIns="0" rIns="0" bIns="0" rtlCol="0" anchor="t"/>
+          <a:lstStyle/>
+          <a:p>
+            <a:pPr algn="l" indent="0" marL="0">
+              <a:lnSpc>
+                <a:spcPct val="112000"/>
+              </a:lnSpc>
+              <a:buNone/>
+            </a:pPr>
+            <a:r>
+              <a:rPr lang="en-US" sz="790" b="1" spc="80" kern="0" dirty="0">
+                <a:solidFill>
+                  <a:srgbClr val="6B7484"/>
+                </a:solidFill>
+                <a:latin typeface="Inter" pitchFamily="34" charset="0"/>
+                <a:ea typeface="Inter" pitchFamily="34" charset="-122"/>
+                <a:cs typeface="Inter" pitchFamily="34" charset="-120"/>
+              </a:rPr>
+              <a:t>DUEÑO</a:t>
+            </a:r>
+            <a:endParaRPr lang="en-US" sz="790" dirty="0"/>
+          </a:p>
+        </p:txBody>
+      </p:sp>
+      <p:sp>
+        <p:nvSpPr>
+          <p:cNvPr id="25" name="Text 23"/>
+          <p:cNvSpPr txBox="1"/>
+          <p:nvPr/>
+        </p:nvSpPr>
+        <p:spPr>
+          <a:xfrm>
+            <a:off x="9070527" y="1900733"/>
+            <a:ext cx="2705776" cy="390184"/>
+          </a:xfrm>
+          <a:prstGeom prst="rect">
+            <a:avLst/>
+          </a:prstGeom>
+          <a:noFill/>
+          <a:ln/>
+        </p:spPr>
+        <p:txBody>
+          <a:bodyPr wrap="square" lIns="0" tIns="0" rIns="0" bIns="0" rtlCol="0" anchor="t"/>
+          <a:lstStyle/>
+          <a:p>
+            <a:pPr algn="l" indent="0" marL="0">
+              <a:lnSpc>
+                <a:spcPct val="83000"/>
+              </a:lnSpc>
+              <a:buNone/>
+            </a:pPr>
+            <a:r>
+              <a:rPr lang="en-US" sz="3070" b="1" spc="-60" kern="0" dirty="0">
+                <a:solidFill>
+                  <a:srgbClr val="0B1220"/>
+                </a:solidFill>
+                <a:latin typeface="Inter" pitchFamily="34" charset="0"/>
+                <a:ea typeface="Inter" pitchFamily="34" charset="-122"/>
+                <a:cs typeface="Inter" pitchFamily="34" charset="-120"/>
+              </a:rPr>
+              <a:t>74</a:t>
+            </a:r>
+            <a:endParaRPr lang="en-US" sz="3070" dirty="0"/>
+          </a:p>
+        </p:txBody>
+      </p:sp>
+      <p:sp>
+        <p:nvSpPr>
+          <p:cNvPr id="26" name="Text 24"/>
+          <p:cNvSpPr txBox="1"/>
+          <p:nvPr/>
+        </p:nvSpPr>
+        <p:spPr>
+          <a:xfrm>
+            <a:off x="9070527" y="2345774"/>
+            <a:ext cx="2705776" cy="567417"/>
+          </a:xfrm>
+          <a:prstGeom prst="rect">
+            <a:avLst/>
+          </a:prstGeom>
+          <a:noFill/>
+          <a:ln/>
+        </p:spPr>
+        <p:txBody>
+          <a:bodyPr wrap="square" lIns="0" tIns="0" rIns="0" bIns="0" rtlCol="0" anchor="t"/>
+          <a:lstStyle/>
+          <a:p>
+            <a:pPr algn="l" indent="0" marL="0">
+              <a:lnSpc>
+                <a:spcPct val="112000"/>
+              </a:lnSpc>
+              <a:buNone/>
+            </a:pPr>
+            <a:r>
+              <a:rPr lang="en-US" sz="1100" dirty="0">
+                <a:solidFill>
+                  <a:srgbClr val="3B4556"/>
+                </a:solidFill>
+                <a:latin typeface="Inter" pitchFamily="34" charset="0"/>
+                <a:ea typeface="Inter" pitchFamily="34" charset="-122"/>
+                <a:cs typeface="Inter" pitchFamily="34" charset="-120"/>
+              </a:rPr>
+              <a:t>campañas se copiaron cinco o más veces en vez de medirse: 667 versiones</a:t>
+            </a:r>
+            <a:endParaRPr lang="en-US" sz="1100" dirty="0"/>
+          </a:p>
+        </p:txBody>
+      </p:sp>
+      <p:sp>
+        <p:nvSpPr>
+          <p:cNvPr id="27" name="Shape 25"/>
+          <p:cNvSpPr/>
+          <p:nvPr/>
+        </p:nvSpPr>
+        <p:spPr>
+          <a:xfrm>
+            <a:off x="511956" y="3190946"/>
+            <a:ext cx="2609061" cy="0"/>
+          </a:xfrm>
+          <a:prstGeom prst="line">
+            <a:avLst/>
+          </a:prstGeom>
+          <a:noFill/>
+          <a:ln w="19291">
+            <a:solidFill>
+              <a:srgbClr val="0B1220"/>
+            </a:solidFill>
+            <a:prstDash val="solid"/>
+          </a:ln>
+        </p:spPr>
+      </p:sp>
+      <p:sp>
+        <p:nvSpPr>
+          <p:cNvPr id="28" name="Text 26"/>
+          <p:cNvSpPr txBox="1"/>
+          <p:nvPr/>
+        </p:nvSpPr>
+        <p:spPr>
+          <a:xfrm>
+            <a:off x="511956" y="3310307"/>
+            <a:ext cx="2705621" cy="134884"/>
+          </a:xfrm>
+          <a:prstGeom prst="rect">
+            <a:avLst/>
+          </a:prstGeom>
+          <a:noFill/>
+          <a:ln/>
+        </p:spPr>
+        <p:txBody>
+          <a:bodyPr wrap="square" lIns="0" tIns="0" rIns="0" bIns="0" rtlCol="0" anchor="t"/>
+          <a:lstStyle/>
+          <a:p>
+            <a:pPr algn="l" indent="0" marL="0">
+              <a:lnSpc>
+                <a:spcPct val="112000"/>
+              </a:lnSpc>
+              <a:buNone/>
+            </a:pPr>
+            <a:r>
+              <a:rPr lang="en-US" sz="790" b="1" spc="80" kern="0" dirty="0">
+                <a:solidFill>
+                  <a:srgbClr val="6B7484"/>
+                </a:solidFill>
+                <a:latin typeface="Inter" pitchFamily="34" charset="0"/>
+                <a:ea typeface="Inter" pitchFamily="34" charset="-122"/>
+                <a:cs typeface="Inter" pitchFamily="34" charset="-120"/>
+              </a:rPr>
+              <a:t>REGLAS</a:t>
+            </a:r>
+            <a:endParaRPr lang="en-US" sz="790" dirty="0"/>
+          </a:p>
+        </p:txBody>
+      </p:sp>
+      <p:sp>
+        <p:nvSpPr>
+          <p:cNvPr id="29" name="Text 27"/>
+          <p:cNvSpPr txBox="1"/>
+          <p:nvPr/>
+        </p:nvSpPr>
+        <p:spPr>
+          <a:xfrm>
+            <a:off x="511956" y="3500049"/>
+            <a:ext cx="2705621" cy="390184"/>
+          </a:xfrm>
+          <a:prstGeom prst="rect">
+            <a:avLst/>
+          </a:prstGeom>
+          <a:noFill/>
+          <a:ln/>
+        </p:spPr>
+        <p:txBody>
+          <a:bodyPr wrap="square" lIns="0" tIns="0" rIns="0" bIns="0" rtlCol="0" anchor="t"/>
+          <a:lstStyle/>
+          <a:p>
+            <a:pPr algn="l" indent="0" marL="0">
+              <a:lnSpc>
+                <a:spcPct val="83000"/>
+              </a:lnSpc>
+              <a:buNone/>
+            </a:pPr>
+            <a:r>
+              <a:rPr lang="en-US" sz="3070" b="1" spc="-60" kern="0" dirty="0">
+                <a:solidFill>
+                  <a:srgbClr val="1F4FD8"/>
+                </a:solidFill>
+                <a:latin typeface="Inter" pitchFamily="34" charset="0"/>
+                <a:ea typeface="Inter" pitchFamily="34" charset="-122"/>
+                <a:cs typeface="Inter" pitchFamily="34" charset="-120"/>
+              </a:rPr>
+              <a:t>43 M</a:t>
+            </a:r>
+            <a:endParaRPr lang="en-US" sz="3070" dirty="0"/>
+          </a:p>
+        </p:txBody>
+      </p:sp>
+      <p:sp>
+        <p:nvSpPr>
+          <p:cNvPr id="30" name="Text 28"/>
+          <p:cNvSpPr txBox="1"/>
+          <p:nvPr/>
+        </p:nvSpPr>
+        <p:spPr>
+          <a:xfrm>
+            <a:off x="511956" y="3945090"/>
+            <a:ext cx="2705621" cy="378278"/>
+          </a:xfrm>
+          <a:prstGeom prst="rect">
+            <a:avLst/>
+          </a:prstGeom>
+          <a:noFill/>
+          <a:ln/>
+        </p:spPr>
+        <p:txBody>
+          <a:bodyPr wrap="square" lIns="0" tIns="0" rIns="0" bIns="0" rtlCol="0" anchor="t"/>
+          <a:lstStyle/>
+          <a:p>
+            <a:pPr algn="l" indent="0" marL="0">
+              <a:lnSpc>
+                <a:spcPct val="112000"/>
+              </a:lnSpc>
+              <a:buNone/>
+            </a:pPr>
+            <a:r>
+              <a:rPr lang="en-US" sz="1100" dirty="0">
+                <a:solidFill>
+                  <a:srgbClr val="3B4556"/>
+                </a:solidFill>
+                <a:latin typeface="Inter" pitchFamily="34" charset="0"/>
+                <a:ea typeface="Inter" pitchFamily="34" charset="-122"/>
+                <a:cs typeface="Inter" pitchFamily="34" charset="-120"/>
+              </a:rPr>
+              <a:t>promociones a personas con KPay congelado</a:t>
+            </a:r>
+            <a:endParaRPr lang="en-US" sz="1100" dirty="0"/>
+          </a:p>
+        </p:txBody>
+      </p:sp>
+      <p:sp>
+        <p:nvSpPr>
+          <p:cNvPr id="31" name="Shape 29"/>
+          <p:cNvSpPr/>
+          <p:nvPr/>
+        </p:nvSpPr>
+        <p:spPr>
+          <a:xfrm>
+            <a:off x="3364713" y="3190946"/>
+            <a:ext cx="2609212" cy="0"/>
+          </a:xfrm>
+          <a:prstGeom prst="line">
+            <a:avLst/>
+          </a:prstGeom>
+          <a:noFill/>
+          <a:ln w="19291">
+            <a:solidFill>
+              <a:srgbClr val="0B1220"/>
+            </a:solidFill>
+            <a:prstDash val="solid"/>
+          </a:ln>
+        </p:spPr>
+      </p:sp>
+      <p:sp>
+        <p:nvSpPr>
+          <p:cNvPr id="32" name="Text 30"/>
+          <p:cNvSpPr txBox="1"/>
+          <p:nvPr/>
+        </p:nvSpPr>
+        <p:spPr>
+          <a:xfrm>
+            <a:off x="3364713" y="3310307"/>
+            <a:ext cx="2705776" cy="134884"/>
+          </a:xfrm>
+          <a:prstGeom prst="rect">
+            <a:avLst/>
+          </a:prstGeom>
+          <a:noFill/>
+          <a:ln/>
+        </p:spPr>
+        <p:txBody>
+          <a:bodyPr wrap="square" lIns="0" tIns="0" rIns="0" bIns="0" rtlCol="0" anchor="t"/>
+          <a:lstStyle/>
+          <a:p>
+            <a:pPr algn="l" indent="0" marL="0">
+              <a:lnSpc>
+                <a:spcPct val="112000"/>
+              </a:lnSpc>
+              <a:buNone/>
+            </a:pPr>
+            <a:r>
+              <a:rPr lang="en-US" sz="790" b="1" spc="80" kern="0" dirty="0">
+                <a:solidFill>
+                  <a:srgbClr val="6B7484"/>
+                </a:solidFill>
+                <a:latin typeface="Inter" pitchFamily="34" charset="0"/>
+                <a:ea typeface="Inter" pitchFamily="34" charset="-122"/>
+                <a:cs typeface="Inter" pitchFamily="34" charset="-120"/>
+              </a:rPr>
+              <a:t>REGLAS</a:t>
+            </a:r>
+            <a:endParaRPr lang="en-US" sz="790" dirty="0"/>
+          </a:p>
+        </p:txBody>
+      </p:sp>
+      <p:sp>
+        <p:nvSpPr>
+          <p:cNvPr id="33" name="Text 31"/>
+          <p:cNvSpPr txBox="1"/>
+          <p:nvPr/>
+        </p:nvSpPr>
+        <p:spPr>
+          <a:xfrm>
+            <a:off x="3364713" y="3500049"/>
+            <a:ext cx="2705776" cy="390184"/>
+          </a:xfrm>
+          <a:prstGeom prst="rect">
+            <a:avLst/>
+          </a:prstGeom>
+          <a:noFill/>
+          <a:ln/>
+        </p:spPr>
+        <p:txBody>
+          <a:bodyPr wrap="square" lIns="0" tIns="0" rIns="0" bIns="0" rtlCol="0" anchor="t"/>
+          <a:lstStyle/>
+          <a:p>
+            <a:pPr algn="l" indent="0" marL="0">
+              <a:lnSpc>
+                <a:spcPct val="83000"/>
+              </a:lnSpc>
+              <a:buNone/>
+            </a:pPr>
+            <a:r>
+              <a:rPr lang="en-US" sz="3070" b="1" spc="-60" kern="0" dirty="0">
+                <a:solidFill>
+                  <a:srgbClr val="1F4FD8"/>
+                </a:solidFill>
+                <a:latin typeface="Inter" pitchFamily="34" charset="0"/>
+                <a:ea typeface="Inter" pitchFamily="34" charset="-122"/>
+                <a:cs typeface="Inter" pitchFamily="34" charset="-120"/>
+              </a:rPr>
+              <a:t>9.8 M</a:t>
+            </a:r>
+            <a:endParaRPr lang="en-US" sz="3070" dirty="0"/>
+          </a:p>
+        </p:txBody>
+      </p:sp>
+      <p:sp>
+        <p:nvSpPr>
+          <p:cNvPr id="34" name="Text 32"/>
+          <p:cNvSpPr txBox="1"/>
+          <p:nvPr/>
+        </p:nvSpPr>
+        <p:spPr>
+          <a:xfrm>
+            <a:off x="3364713" y="3945090"/>
+            <a:ext cx="2705776" cy="378278"/>
+          </a:xfrm>
+          <a:prstGeom prst="rect">
+            <a:avLst/>
+          </a:prstGeom>
+          <a:noFill/>
+          <a:ln/>
+        </p:spPr>
+        <p:txBody>
+          <a:bodyPr wrap="square" lIns="0" tIns="0" rIns="0" bIns="0" rtlCol="0" anchor="t"/>
+          <a:lstStyle/>
+          <a:p>
+            <a:pPr algn="l" indent="0" marL="0">
+              <a:lnSpc>
+                <a:spcPct val="112000"/>
+              </a:lnSpc>
+              <a:buNone/>
+            </a:pPr>
+            <a:r>
+              <a:rPr lang="en-US" sz="1100" dirty="0">
+                <a:solidFill>
+                  <a:srgbClr val="3B4556"/>
+                </a:solidFill>
+                <a:latin typeface="Inter" pitchFamily="34" charset="0"/>
+                <a:ea typeface="Inter" pitchFamily="34" charset="-122"/>
+                <a:cs typeface="Inter" pitchFamily="34" charset="-120"/>
+              </a:rPr>
+              <a:t>WhatsApp a personas marcadas como baja</a:t>
+            </a:r>
+            <a:endParaRPr lang="en-US" sz="1100" dirty="0"/>
+          </a:p>
+        </p:txBody>
+      </p:sp>
+      <p:sp>
+        <p:nvSpPr>
+          <p:cNvPr id="35" name="Shape 33"/>
+          <p:cNvSpPr/>
+          <p:nvPr/>
+        </p:nvSpPr>
+        <p:spPr>
+          <a:xfrm>
+            <a:off x="6217620" y="3190946"/>
+            <a:ext cx="2609212" cy="0"/>
+          </a:xfrm>
+          <a:prstGeom prst="line">
+            <a:avLst/>
+          </a:prstGeom>
+          <a:noFill/>
+          <a:ln w="19291">
+            <a:solidFill>
+              <a:srgbClr val="0B1220"/>
+            </a:solidFill>
+            <a:prstDash val="solid"/>
+          </a:ln>
+        </p:spPr>
+      </p:sp>
+      <p:sp>
+        <p:nvSpPr>
+          <p:cNvPr id="36" name="Text 34"/>
+          <p:cNvSpPr txBox="1"/>
+          <p:nvPr/>
+        </p:nvSpPr>
+        <p:spPr>
+          <a:xfrm>
+            <a:off x="6217620" y="3310307"/>
+            <a:ext cx="2705776" cy="134884"/>
+          </a:xfrm>
+          <a:prstGeom prst="rect">
+            <a:avLst/>
+          </a:prstGeom>
+          <a:noFill/>
+          <a:ln/>
+        </p:spPr>
+        <p:txBody>
+          <a:bodyPr wrap="square" lIns="0" tIns="0" rIns="0" bIns="0" rtlCol="0" anchor="t"/>
+          <a:lstStyle/>
+          <a:p>
+            <a:pPr algn="l" indent="0" marL="0">
+              <a:lnSpc>
+                <a:spcPct val="112000"/>
+              </a:lnSpc>
+              <a:buNone/>
+            </a:pPr>
+            <a:r>
+              <a:rPr lang="en-US" sz="790" b="1" spc="80" kern="0" dirty="0">
+                <a:solidFill>
+                  <a:srgbClr val="6B7484"/>
+                </a:solidFill>
+                <a:latin typeface="Inter" pitchFamily="34" charset="0"/>
+                <a:ea typeface="Inter" pitchFamily="34" charset="-122"/>
+                <a:cs typeface="Inter" pitchFamily="34" charset="-120"/>
+              </a:rPr>
+              <a:t>REGLAS</a:t>
+            </a:r>
+            <a:endParaRPr lang="en-US" sz="790" dirty="0"/>
+          </a:p>
+        </p:txBody>
+      </p:sp>
+      <p:sp>
+        <p:nvSpPr>
+          <p:cNvPr id="37" name="Text 35"/>
+          <p:cNvSpPr txBox="1"/>
+          <p:nvPr/>
+        </p:nvSpPr>
+        <p:spPr>
+          <a:xfrm>
+            <a:off x="6217620" y="3500049"/>
+            <a:ext cx="2705776" cy="390184"/>
+          </a:xfrm>
+          <a:prstGeom prst="rect">
+            <a:avLst/>
+          </a:prstGeom>
+          <a:noFill/>
+          <a:ln/>
+        </p:spPr>
+        <p:txBody>
+          <a:bodyPr wrap="square" lIns="0" tIns="0" rIns="0" bIns="0" rtlCol="0" anchor="t"/>
+          <a:lstStyle/>
+          <a:p>
+            <a:pPr algn="l" indent="0" marL="0">
+              <a:lnSpc>
+                <a:spcPct val="83000"/>
+              </a:lnSpc>
+              <a:buNone/>
+            </a:pPr>
+            <a:r>
+              <a:rPr lang="en-US" sz="3070" b="1" spc="-60" kern="0" dirty="0">
+                <a:solidFill>
+                  <a:srgbClr val="1F4FD8"/>
+                </a:solidFill>
+                <a:latin typeface="Inter" pitchFamily="34" charset="0"/>
+                <a:ea typeface="Inter" pitchFamily="34" charset="-122"/>
+                <a:cs typeface="Inter" pitchFamily="34" charset="-120"/>
+              </a:rPr>
+              <a:t>9.9 M</a:t>
+            </a:r>
+            <a:endParaRPr lang="en-US" sz="3070" dirty="0"/>
+          </a:p>
+        </p:txBody>
+      </p:sp>
+      <p:sp>
+        <p:nvSpPr>
+          <p:cNvPr id="38" name="Text 36"/>
+          <p:cNvSpPr txBox="1"/>
+          <p:nvPr/>
+        </p:nvSpPr>
+        <p:spPr>
+          <a:xfrm>
+            <a:off x="6217620" y="3945090"/>
+            <a:ext cx="2705776" cy="378278"/>
+          </a:xfrm>
+          <a:prstGeom prst="rect">
+            <a:avLst/>
+          </a:prstGeom>
+          <a:noFill/>
+          <a:ln/>
+        </p:spPr>
+        <p:txBody>
+          <a:bodyPr wrap="square" lIns="0" tIns="0" rIns="0" bIns="0" rtlCol="0" anchor="t"/>
+          <a:lstStyle/>
+          <a:p>
+            <a:pPr algn="l" indent="0" marL="0">
+              <a:lnSpc>
+                <a:spcPct val="112000"/>
+              </a:lnSpc>
+              <a:buNone/>
+            </a:pPr>
+            <a:r>
+              <a:rPr lang="en-US" sz="1100" dirty="0">
+                <a:solidFill>
+                  <a:srgbClr val="3B4556"/>
+                </a:solidFill>
+                <a:latin typeface="Inter" pitchFamily="34" charset="0"/>
+                <a:ea typeface="Inter" pitchFamily="34" charset="-122"/>
+                <a:cs typeface="Inter" pitchFamily="34" charset="-120"/>
+              </a:rPr>
+              <a:t>veces una persona recibió la misma campaña dos veces el mismo día</a:t>
+            </a:r>
+            <a:endParaRPr lang="en-US" sz="1100" dirty="0"/>
+          </a:p>
+        </p:txBody>
+      </p:sp>
+      <p:sp>
+        <p:nvSpPr>
+          <p:cNvPr id="39" name="Shape 37"/>
+          <p:cNvSpPr/>
+          <p:nvPr/>
+        </p:nvSpPr>
+        <p:spPr>
+          <a:xfrm>
+            <a:off x="9070527" y="3190946"/>
+            <a:ext cx="2609212" cy="0"/>
+          </a:xfrm>
+          <a:prstGeom prst="line">
+            <a:avLst/>
+          </a:prstGeom>
+          <a:noFill/>
+          <a:ln w="19291">
+            <a:solidFill>
+              <a:srgbClr val="0B1220"/>
+            </a:solidFill>
+            <a:prstDash val="solid"/>
+          </a:ln>
+        </p:spPr>
+      </p:sp>
+      <p:sp>
+        <p:nvSpPr>
+          <p:cNvPr id="40" name="Text 38"/>
+          <p:cNvSpPr txBox="1"/>
+          <p:nvPr/>
+        </p:nvSpPr>
+        <p:spPr>
+          <a:xfrm>
+            <a:off x="9070527" y="3310307"/>
+            <a:ext cx="2705776" cy="134884"/>
+          </a:xfrm>
+          <a:prstGeom prst="rect">
+            <a:avLst/>
+          </a:prstGeom>
+          <a:noFill/>
+          <a:ln/>
+        </p:spPr>
+        <p:txBody>
+          <a:bodyPr wrap="square" lIns="0" tIns="0" rIns="0" bIns="0" rtlCol="0" anchor="t"/>
+          <a:lstStyle/>
+          <a:p>
+            <a:pPr algn="l" indent="0" marL="0">
+              <a:lnSpc>
+                <a:spcPct val="112000"/>
+              </a:lnSpc>
+              <a:buNone/>
+            </a:pPr>
+            <a:r>
+              <a:rPr lang="en-US" sz="790" b="1" spc="80" kern="0" dirty="0">
+                <a:solidFill>
+                  <a:srgbClr val="6B7484"/>
+                </a:solidFill>
+                <a:latin typeface="Inter" pitchFamily="34" charset="0"/>
+                <a:ea typeface="Inter" pitchFamily="34" charset="-122"/>
+                <a:cs typeface="Inter" pitchFamily="34" charset="-120"/>
+              </a:rPr>
+              <a:t>MEDICIÓN</a:t>
+            </a:r>
+            <a:endParaRPr lang="en-US" sz="790" dirty="0"/>
+          </a:p>
+        </p:txBody>
+      </p:sp>
+      <p:sp>
+        <p:nvSpPr>
+          <p:cNvPr id="41" name="Text 39"/>
+          <p:cNvSpPr txBox="1"/>
+          <p:nvPr/>
+        </p:nvSpPr>
+        <p:spPr>
+          <a:xfrm>
+            <a:off x="9070527" y="3500049"/>
+            <a:ext cx="2705776" cy="390184"/>
+          </a:xfrm>
+          <a:prstGeom prst="rect">
+            <a:avLst/>
+          </a:prstGeom>
+          <a:noFill/>
+          <a:ln/>
+        </p:spPr>
+        <p:txBody>
+          <a:bodyPr wrap="square" lIns="0" tIns="0" rIns="0" bIns="0" rtlCol="0" anchor="t"/>
+          <a:lstStyle/>
+          <a:p>
+            <a:pPr algn="l" indent="0" marL="0">
+              <a:lnSpc>
+                <a:spcPct val="83000"/>
+              </a:lnSpc>
+              <a:buNone/>
+            </a:pPr>
+            <a:r>
+              <a:rPr lang="en-US" sz="3070" b="1" spc="-60" kern="0" dirty="0">
+                <a:solidFill>
+                  <a:srgbClr val="1F4FD8"/>
+                </a:solidFill>
+                <a:latin typeface="Inter" pitchFamily="34" charset="0"/>
+                <a:ea typeface="Inter" pitchFamily="34" charset="-122"/>
+                <a:cs typeface="Inter" pitchFamily="34" charset="-120"/>
+              </a:rPr>
+              <a:t>1 de 3,228</a:t>
+            </a:r>
+            <a:endParaRPr lang="en-US" sz="3070" dirty="0"/>
+          </a:p>
+        </p:txBody>
+      </p:sp>
+      <p:sp>
+        <p:nvSpPr>
+          <p:cNvPr id="42" name="Text 40"/>
+          <p:cNvSpPr txBox="1"/>
+          <p:nvPr/>
+        </p:nvSpPr>
+        <p:spPr>
+          <a:xfrm>
+            <a:off x="9070527" y="3945090"/>
+            <a:ext cx="2705776" cy="567417"/>
+          </a:xfrm>
+          <a:prstGeom prst="rect">
+            <a:avLst/>
+          </a:prstGeom>
+          <a:noFill/>
+          <a:ln/>
+        </p:spPr>
+        <p:txBody>
+          <a:bodyPr wrap="square" lIns="0" tIns="0" rIns="0" bIns="0" rtlCol="0" anchor="t"/>
+          <a:lstStyle/>
+          <a:p>
+            <a:pPr algn="l" indent="0" marL="0">
+              <a:lnSpc>
+                <a:spcPct val="112000"/>
+              </a:lnSpc>
+              <a:buNone/>
+            </a:pPr>
+            <a:r>
+              <a:rPr lang="en-US" sz="1100" dirty="0">
+                <a:solidFill>
+                  <a:srgbClr val="3B4556"/>
+                </a:solidFill>
+                <a:latin typeface="Inter" pitchFamily="34" charset="0"/>
+                <a:ea typeface="Inter" pitchFamily="34" charset="-122"/>
+                <a:cs typeface="Inter" pitchFamily="34" charset="-120"/>
+              </a:rPr>
+              <a:t>Canvas tiene grupo de control real; solo el correo registra bajas por campaña</a:t>
+            </a:r>
+            <a:endParaRPr lang="en-US" sz="1100" dirty="0"/>
+          </a:p>
+        </p:txBody>
+      </p:sp>
+      <p:sp>
+        <p:nvSpPr>
+          <p:cNvPr id="43" name="Shape 41"/>
+          <p:cNvSpPr/>
+          <p:nvPr/>
+        </p:nvSpPr>
+        <p:spPr>
+          <a:xfrm>
+            <a:off x="511956" y="5992160"/>
+            <a:ext cx="11167783" cy="352808"/>
+          </a:xfrm>
+          <a:prstGeom prst="rect">
             <a:avLst/>
           </a:prstGeom>
           <a:solidFill>
@@ -4754,33 +5855,503 @@
       </p:sp>
       <p:sp>
         <p:nvSpPr>
-          <p:cNvPr id="18" name="Text 16"/>
-          <p:cNvSpPr txBox="1"/>
-          <p:nvPr/>
-        </p:nvSpPr>
-        <p:spPr>
-          <a:xfrm>
-            <a:off x="4331958" y="2922987"/>
-            <a:ext cx="256876" cy="231639"/>
-          </a:xfrm>
-          <a:prstGeom prst="rect">
-            <a:avLst/>
-          </a:prstGeom>
-          <a:noFill/>
-          <a:ln/>
-        </p:spPr>
-        <p:txBody>
-          <a:bodyPr wrap="square" lIns="0" tIns="0" rIns="0" bIns="0" rtlCol="0" anchor="ctr"/>
-          <a:lstStyle/>
-          <a:p>
-            <a:pPr algn="ctr" indent="0" marL="0">
+          <p:cNvPr id="44" name="Text 42"/>
+          <p:cNvSpPr txBox="1"/>
+          <p:nvPr/>
+        </p:nvSpPr>
+        <p:spPr>
+          <a:xfrm>
+            <a:off x="670350" y="6116043"/>
+            <a:ext cx="616853" cy="134733"/>
+          </a:xfrm>
+          <a:prstGeom prst="rect">
+            <a:avLst/>
+          </a:prstGeom>
+          <a:noFill/>
+          <a:ln/>
+        </p:spPr>
+        <p:txBody>
+          <a:bodyPr wrap="square" lIns="0" tIns="0" rIns="0" bIns="0" rtlCol="0" anchor="t"/>
+          <a:lstStyle/>
+          <a:p>
+            <a:pPr algn="l" indent="0" marL="0">
+              <a:lnSpc>
+                <a:spcPct val="107000"/>
+              </a:lnSpc>
+              <a:buNone/>
+            </a:pPr>
+            <a:r>
+              <a:rPr lang="en-US" sz="820" b="1" spc="100" kern="0" dirty="0">
+                <a:solidFill>
+                  <a:srgbClr val="1F4FD8"/>
+                </a:solidFill>
+                <a:latin typeface="Inter" pitchFamily="34" charset="0"/>
+                <a:ea typeface="Inter" pitchFamily="34" charset="-122"/>
+                <a:cs typeface="Inter" pitchFamily="34" charset="-120"/>
+              </a:rPr>
+              <a:t>SO WHAT</a:t>
+            </a:r>
+            <a:endParaRPr lang="en-US" sz="820" dirty="0"/>
+          </a:p>
+        </p:txBody>
+      </p:sp>
+      <p:sp>
+        <p:nvSpPr>
+          <p:cNvPr id="45" name="Text 43"/>
+          <p:cNvSpPr txBox="1"/>
+          <p:nvPr/>
+        </p:nvSpPr>
+        <p:spPr>
+          <a:xfrm>
+            <a:off x="1409876" y="6077461"/>
+            <a:ext cx="6359879" cy="182206"/>
+          </a:xfrm>
+          <a:prstGeom prst="rect">
+            <a:avLst/>
+          </a:prstGeom>
+          <a:noFill/>
+          <a:ln/>
+        </p:spPr>
+        <p:txBody>
+          <a:bodyPr wrap="square" lIns="0" tIns="0" rIns="0" bIns="0" rtlCol="0" anchor="t"/>
+          <a:lstStyle/>
+          <a:p>
+            <a:pPr algn="l" indent="0" marL="0">
+              <a:lnSpc>
+                <a:spcPct val="107000"/>
+              </a:lnSpc>
+              <a:buNone/>
+            </a:pPr>
+            <a:r>
+              <a:rPr lang="en-US" sz="1100" dirty="0">
+                <a:solidFill>
+                  <a:srgbClr val="0B1220"/>
+                </a:solidFill>
+                <a:latin typeface="Inter" pitchFamily="34" charset="0"/>
+                <a:ea typeface="Inter" pitchFamily="34" charset="-122"/>
+                <a:cs typeface="Inter" pitchFamily="34" charset="-120"/>
+              </a:rPr>
+              <a:t>No es una campaña mala: es una cuenta sin dueño, sin reglas comunes y sin forma de medir.</a:t>
+            </a:r>
+            <a:endParaRPr lang="en-US" sz="1100" dirty="0"/>
+          </a:p>
+        </p:txBody>
+      </p:sp>
+      <p:sp>
+        <p:nvSpPr>
+          <p:cNvPr id="46" name="Text 44"/>
+          <p:cNvSpPr txBox="1"/>
+          <p:nvPr/>
+        </p:nvSpPr>
+        <p:spPr>
+          <a:xfrm>
+            <a:off x="511956" y="6454684"/>
+            <a:ext cx="8526262" cy="135035"/>
+          </a:xfrm>
+          <a:prstGeom prst="rect">
+            <a:avLst/>
+          </a:prstGeom>
+          <a:noFill/>
+          <a:ln/>
+        </p:spPr>
+        <p:txBody>
+          <a:bodyPr wrap="square" lIns="0" tIns="0" rIns="0" bIns="0" rtlCol="0" anchor="t"/>
+          <a:lstStyle/>
+          <a:p>
+            <a:pPr algn="l" indent="0" marL="0">
+              <a:lnSpc>
+                <a:spcPct val="99000"/>
+              </a:lnSpc>
+              <a:buNone/>
+            </a:pPr>
+            <a:r>
+              <a:rPr lang="en-US" sz="840" dirty="0">
+                <a:solidFill>
+                  <a:srgbClr val="6B7484"/>
+                </a:solidFill>
+                <a:latin typeface="Inter" pitchFamily="34" charset="0"/>
+                <a:ea typeface="Inter" pitchFamily="34" charset="-122"/>
+                <a:cs typeface="Inter" pitchFamily="34" charset="-120"/>
+              </a:rPr>
+              <a:t>Fuente: Braze, catálogo de campañas y Canvas, envíos por comunicación (E1, E2), bloqueados (E7a, Sheets v4), grupos de control (E13), enero a septiembre 2026.</a:t>
+            </a:r>
+            <a:endParaRPr lang="en-US" sz="840" dirty="0"/>
+          </a:p>
+        </p:txBody>
+      </p:sp>
+      <p:sp>
+        <p:nvSpPr>
+          <p:cNvPr id="47" name="Text 45"/>
+          <p:cNvSpPr txBox="1"/>
+          <p:nvPr/>
+        </p:nvSpPr>
+        <p:spPr>
+          <a:xfrm>
+            <a:off x="11570777" y="6454684"/>
+            <a:ext cx="130519" cy="135035"/>
+          </a:xfrm>
+          <a:prstGeom prst="rect">
+            <a:avLst/>
+          </a:prstGeom>
+          <a:noFill/>
+          <a:ln/>
+        </p:spPr>
+        <p:txBody>
+          <a:bodyPr wrap="square" lIns="0" tIns="0" rIns="0" bIns="0" rtlCol="0" anchor="t"/>
+          <a:lstStyle/>
+          <a:p>
+            <a:pPr algn="l" indent="0" marL="0">
+              <a:lnSpc>
+                <a:spcPct val="99000"/>
+              </a:lnSpc>
+              <a:buNone/>
+            </a:pPr>
+            <a:r>
+              <a:rPr lang="en-US" sz="840" dirty="0">
+                <a:solidFill>
+                  <a:srgbClr val="6B7484"/>
+                </a:solidFill>
+                <a:latin typeface="Inter" pitchFamily="34" charset="0"/>
+                <a:ea typeface="Inter" pitchFamily="34" charset="-122"/>
+                <a:cs typeface="Inter" pitchFamily="34" charset="-120"/>
+              </a:rPr>
+              <a:t>12</a:t>
+            </a:r>
+            <a:endParaRPr lang="en-US" sz="840" dirty="0"/>
+          </a:p>
+        </p:txBody>
+      </p:sp>
+    </p:spTree>
+  </p:cSld>
+  <p:clrMapOvr>
+    <a:masterClrMapping/>
+  </p:clrMapOvr>
+</p:sld>
+</file>
+
+<file path=ppt/slides/slide13.xml><?xml version="1.0" encoding="utf-8"?>
+<p:sld xmlns:a="http://schemas.openxmlformats.org/drawingml/2006/main" xmlns:r="http://schemas.openxmlformats.org/officeDocument/2006/relationships" xmlns:p="http://schemas.openxmlformats.org/presentationml/2006/main">
+  <p:cSld name="Slide 13">
+    <p:bg>
+      <p:bgPr>
+        <a:solidFill>
+          <a:srgbClr val="FFFFFF"/>
+        </a:solidFill>
+      </p:bgPr>
+    </p:bg>
+    <p:spTree>
+      <p:nvGrpSpPr>
+        <p:cNvPr id="1" name=""/>
+        <p:cNvGrpSpPr/>
+        <p:nvPr/>
+      </p:nvGrpSpPr>
+      <p:grpSpPr>
+        <a:xfrm>
+          <a:off x="0" y="0"/>
+          <a:ext cx="0" cy="0"/>
+          <a:chOff x="0" y="0"/>
+          <a:chExt cx="0" cy="0"/>
+        </a:xfrm>
+      </p:grpSpPr>
+      <p:sp>
+        <p:nvSpPr>
+          <p:cNvPr id="2" name="Text 0"/>
+          <p:cNvSpPr txBox="1"/>
+          <p:nvPr/>
+        </p:nvSpPr>
+        <p:spPr>
+          <a:xfrm>
+            <a:off x="511956" y="390033"/>
+            <a:ext cx="11521105" cy="661609"/>
+          </a:xfrm>
+          <a:prstGeom prst="rect">
+            <a:avLst/>
+          </a:prstGeom>
+          <a:noFill/>
+          <a:ln/>
+        </p:spPr>
+        <p:txBody>
+          <a:bodyPr wrap="square" lIns="0" tIns="0" rIns="0" bIns="0" rtlCol="0" anchor="t"/>
+          <a:lstStyle/>
+          <a:p>
+            <a:pPr algn="l" indent="0" marL="0">
+              <a:lnSpc>
+                <a:spcPct val="98000"/>
+              </a:lnSpc>
+              <a:buNone/>
+            </a:pPr>
+            <a:r>
+              <a:rPr lang="en-US" sz="2210" b="1" spc="-30" kern="0" dirty="0">
+                <a:solidFill>
+                  <a:srgbClr val="0B1220"/>
+                </a:solidFill>
+                <a:latin typeface="Inter" pitchFamily="34" charset="0"/>
+                <a:ea typeface="Inter" pitchFamily="34" charset="-122"/>
+                <a:cs typeface="Inter" pitchFamily="34" charset="-120"/>
+              </a:rPr>
+              <a:t>Qué lo explica: escribimos por lo que queremos vender, cada equipo por su cuenta y sin medir</a:t>
+            </a:r>
+            <a:endParaRPr lang="en-US" sz="2210" dirty="0"/>
+          </a:p>
+        </p:txBody>
+      </p:sp>
+      <p:sp>
+        <p:nvSpPr>
+          <p:cNvPr id="3" name="Shape 1"/>
+          <p:cNvSpPr/>
+          <p:nvPr/>
+        </p:nvSpPr>
+        <p:spPr>
+          <a:xfrm>
+            <a:off x="511956" y="1161358"/>
+            <a:ext cx="3527477" cy="1398573"/>
+          </a:xfrm>
+          <a:prstGeom prst="rect">
+            <a:avLst/>
+          </a:prstGeom>
+          <a:solidFill>
+            <a:srgbClr val="F4F6F9"/>
+          </a:solidFill>
+          <a:ln/>
+        </p:spPr>
+      </p:sp>
+      <p:sp>
+        <p:nvSpPr>
+          <p:cNvPr id="4" name="Text 2"/>
+          <p:cNvSpPr txBox="1"/>
+          <p:nvPr/>
+        </p:nvSpPr>
+        <p:spPr>
+          <a:xfrm>
+            <a:off x="694765" y="1356374"/>
+            <a:ext cx="3275003" cy="512107"/>
+          </a:xfrm>
+          <a:prstGeom prst="rect">
+            <a:avLst/>
+          </a:prstGeom>
+          <a:noFill/>
+          <a:ln/>
+        </p:spPr>
+        <p:txBody>
+          <a:bodyPr wrap="square" lIns="0" tIns="0" rIns="0" bIns="0" rtlCol="0" anchor="t"/>
+          <a:lstStyle/>
+          <a:p>
+            <a:pPr algn="l" indent="0" marL="0">
+              <a:lnSpc>
+                <a:spcPct val="83000"/>
+              </a:lnSpc>
+              <a:buNone/>
+            </a:pPr>
+            <a:r>
+              <a:rPr lang="en-US" sz="4030" b="1" spc="-80" kern="0" dirty="0">
+                <a:solidFill>
+                  <a:srgbClr val="0B1220"/>
+                </a:solidFill>
+                <a:latin typeface="Inter" pitchFamily="34" charset="0"/>
+                <a:ea typeface="Inter" pitchFamily="34" charset="-122"/>
+                <a:cs typeface="Inter" pitchFamily="34" charset="-120"/>
+              </a:rPr>
+              <a:t>73 %</a:t>
+            </a:r>
+            <a:endParaRPr lang="en-US" sz="4030" dirty="0"/>
+          </a:p>
+        </p:txBody>
+      </p:sp>
+      <p:sp>
+        <p:nvSpPr>
+          <p:cNvPr id="5" name="Text 3"/>
+          <p:cNvSpPr txBox="1"/>
+          <p:nvPr/>
+        </p:nvSpPr>
+        <p:spPr>
+          <a:xfrm>
+            <a:off x="694765" y="1953782"/>
+            <a:ext cx="3275003" cy="411132"/>
+          </a:xfrm>
+          <a:prstGeom prst="rect">
+            <a:avLst/>
+          </a:prstGeom>
+          <a:noFill/>
+          <a:ln/>
+        </p:spPr>
+        <p:txBody>
+          <a:bodyPr wrap="square" lIns="0" tIns="0" rIns="0" bIns="0" rtlCol="0" anchor="t"/>
+          <a:lstStyle/>
+          <a:p>
+            <a:pPr algn="l" indent="0" marL="0">
               <a:lnSpc>
                 <a:spcPct val="112000"/>
               </a:lnSpc>
               <a:buNone/>
             </a:pPr>
             <a:r>
-              <a:rPr lang="en-US" sz="960" b="1" dirty="0">
+              <a:rPr lang="en-US" sz="1200" dirty="0">
+                <a:solidFill>
+                  <a:srgbClr val="0B1220"/>
+                </a:solidFill>
+                <a:latin typeface="Inter" pitchFamily="34" charset="0"/>
+                <a:ea typeface="Inter" pitchFamily="34" charset="-122"/>
+                <a:cs typeface="Inter" pitchFamily="34" charset="-120"/>
+              </a:rPr>
+              <a:t>de las personas no respondió a nada en nueve meses</a:t>
+            </a:r>
+            <a:endParaRPr lang="en-US" sz="1200" dirty="0"/>
+          </a:p>
+        </p:txBody>
+      </p:sp>
+      <p:sp>
+        <p:nvSpPr>
+          <p:cNvPr id="6" name="Shape 4"/>
+          <p:cNvSpPr/>
+          <p:nvPr/>
+        </p:nvSpPr>
+        <p:spPr>
+          <a:xfrm>
+            <a:off x="4331958" y="1161358"/>
+            <a:ext cx="3527628" cy="1398573"/>
+          </a:xfrm>
+          <a:prstGeom prst="rect">
+            <a:avLst/>
+          </a:prstGeom>
+          <a:solidFill>
+            <a:srgbClr val="F4F6F9"/>
+          </a:solidFill>
+          <a:ln/>
+        </p:spPr>
+      </p:sp>
+      <p:sp>
+        <p:nvSpPr>
+          <p:cNvPr id="7" name="Text 5"/>
+          <p:cNvSpPr txBox="1"/>
+          <p:nvPr/>
+        </p:nvSpPr>
+        <p:spPr>
+          <a:xfrm>
+            <a:off x="4514767" y="1356374"/>
+            <a:ext cx="3275158" cy="512107"/>
+          </a:xfrm>
+          <a:prstGeom prst="rect">
+            <a:avLst/>
+          </a:prstGeom>
+          <a:noFill/>
+          <a:ln/>
+        </p:spPr>
+        <p:txBody>
+          <a:bodyPr wrap="square" lIns="0" tIns="0" rIns="0" bIns="0" rtlCol="0" anchor="t"/>
+          <a:lstStyle/>
+          <a:p>
+            <a:pPr algn="l" indent="0" marL="0">
+              <a:lnSpc>
+                <a:spcPct val="83000"/>
+              </a:lnSpc>
+              <a:buNone/>
+            </a:pPr>
+            <a:r>
+              <a:rPr lang="en-US" sz="4030" b="1" spc="-80" kern="0" dirty="0">
+                <a:solidFill>
+                  <a:srgbClr val="0B1220"/>
+                </a:solidFill>
+                <a:latin typeface="Inter" pitchFamily="34" charset="0"/>
+                <a:ea typeface="Inter" pitchFamily="34" charset="-122"/>
+                <a:cs typeface="Inter" pitchFamily="34" charset="-120"/>
+              </a:rPr>
+              <a:t>2.3 M</a:t>
+            </a:r>
+            <a:endParaRPr lang="en-US" sz="4030" dirty="0"/>
+          </a:p>
+        </p:txBody>
+      </p:sp>
+      <p:sp>
+        <p:nvSpPr>
+          <p:cNvPr id="8" name="Text 6"/>
+          <p:cNvSpPr txBox="1"/>
+          <p:nvPr/>
+        </p:nvSpPr>
+        <p:spPr>
+          <a:xfrm>
+            <a:off x="4514767" y="1953782"/>
+            <a:ext cx="3275158" cy="411132"/>
+          </a:xfrm>
+          <a:prstGeom prst="rect">
+            <a:avLst/>
+          </a:prstGeom>
+          <a:noFill/>
+          <a:ln/>
+        </p:spPr>
+        <p:txBody>
+          <a:bodyPr wrap="square" lIns="0" tIns="0" rIns="0" bIns="0" rtlCol="0" anchor="t"/>
+          <a:lstStyle/>
+          <a:p>
+            <a:pPr algn="l" indent="0" marL="0">
+              <a:lnSpc>
+                <a:spcPct val="112000"/>
+              </a:lnSpc>
+              <a:buNone/>
+            </a:pPr>
+            <a:r>
+              <a:rPr lang="en-US" sz="1200" dirty="0">
+                <a:solidFill>
+                  <a:srgbClr val="0B1220"/>
+                </a:solidFill>
+                <a:latin typeface="Inter" pitchFamily="34" charset="0"/>
+                <a:ea typeface="Inter" pitchFamily="34" charset="-122"/>
+                <a:cs typeface="Inter" pitchFamily="34" charset="-120"/>
+              </a:rPr>
+              <a:t>personas al mes con tres o más campañas el mismo día</a:t>
+            </a:r>
+            <a:endParaRPr lang="en-US" sz="1200" dirty="0"/>
+          </a:p>
+        </p:txBody>
+      </p:sp>
+      <p:sp>
+        <p:nvSpPr>
+          <p:cNvPr id="9" name="Shape 7"/>
+          <p:cNvSpPr/>
+          <p:nvPr/>
+        </p:nvSpPr>
+        <p:spPr>
+          <a:xfrm>
+            <a:off x="8152111" y="1161358"/>
+            <a:ext cx="3527477" cy="1398573"/>
+          </a:xfrm>
+          <a:prstGeom prst="rect">
+            <a:avLst/>
+          </a:prstGeom>
+          <a:solidFill>
+            <a:srgbClr val="E8EEFC"/>
+          </a:solidFill>
+          <a:ln/>
+        </p:spPr>
+      </p:sp>
+      <p:sp>
+        <p:nvSpPr>
+          <p:cNvPr id="10" name="Text 8"/>
+          <p:cNvSpPr txBox="1"/>
+          <p:nvPr/>
+        </p:nvSpPr>
+        <p:spPr>
+          <a:xfrm>
+            <a:off x="8334920" y="1356374"/>
+            <a:ext cx="3275003" cy="512107"/>
+          </a:xfrm>
+          <a:prstGeom prst="rect">
+            <a:avLst/>
+          </a:prstGeom>
+          <a:noFill/>
+          <a:ln/>
+        </p:spPr>
+        <p:txBody>
+          <a:bodyPr wrap="square" lIns="0" tIns="0" rIns="0" bIns="0" rtlCol="0" anchor="t"/>
+          <a:lstStyle/>
+          <a:p>
+            <a:pPr algn="l" indent="0" marL="0">
+              <a:lnSpc>
+                <a:spcPct val="83000"/>
+              </a:lnSpc>
+              <a:buNone/>
+            </a:pPr>
+            <a:r>
+              <a:rPr lang="en-US" sz="4030" b="1" spc="-80" kern="0" dirty="0">
                 <a:solidFill>
                   <a:srgbClr val="1F4FD8"/>
                 </a:solidFill>
@@ -4788,41 +6359,41 @@
                 <a:ea typeface="Inter" pitchFamily="34" charset="-122"/>
                 <a:cs typeface="Inter" pitchFamily="34" charset="-120"/>
               </a:rPr>
-              <a:t>2</a:t>
-            </a:r>
-            <a:endParaRPr lang="en-US" sz="960" dirty="0"/>
-          </a:p>
-        </p:txBody>
-      </p:sp>
-      <p:sp>
-        <p:nvSpPr>
-          <p:cNvPr id="19" name="Text 17"/>
-          <p:cNvSpPr txBox="1"/>
-          <p:nvPr/>
-        </p:nvSpPr>
-        <p:spPr>
-          <a:xfrm>
-            <a:off x="4673312" y="2922987"/>
-            <a:ext cx="3300150" cy="1109213"/>
-          </a:xfrm>
-          <a:prstGeom prst="rect">
-            <a:avLst/>
-          </a:prstGeom>
-          <a:noFill/>
-          <a:ln/>
-        </p:spPr>
-        <p:txBody>
-          <a:bodyPr wrap="square" lIns="0" tIns="0" rIns="0" bIns="0" rtlCol="0" anchor="t"/>
-          <a:lstStyle/>
-          <a:p>
-            <a:pPr algn="l" indent="0" marL="0">
-              <a:lnSpc>
-                <a:spcPct val="116000"/>
-              </a:lnSpc>
-              <a:buNone/>
-            </a:pPr>
-            <a:r>
-              <a:rPr lang="en-US" sz="1250" b="1" dirty="0">
+              <a:t>1 de 3,228</a:t>
+            </a:r>
+            <a:endParaRPr lang="en-US" sz="4030" dirty="0"/>
+          </a:p>
+        </p:txBody>
+      </p:sp>
+      <p:sp>
+        <p:nvSpPr>
+          <p:cNvPr id="11" name="Text 9"/>
+          <p:cNvSpPr txBox="1"/>
+          <p:nvPr/>
+        </p:nvSpPr>
+        <p:spPr>
+          <a:xfrm>
+            <a:off x="8334920" y="1953782"/>
+            <a:ext cx="3275003" cy="205566"/>
+          </a:xfrm>
+          <a:prstGeom prst="rect">
+            <a:avLst/>
+          </a:prstGeom>
+          <a:noFill/>
+          <a:ln/>
+        </p:spPr>
+        <p:txBody>
+          <a:bodyPr wrap="square" lIns="0" tIns="0" rIns="0" bIns="0" rtlCol="0" anchor="t"/>
+          <a:lstStyle/>
+          <a:p>
+            <a:pPr algn="l" indent="0" marL="0">
+              <a:lnSpc>
+                <a:spcPct val="112000"/>
+              </a:lnSpc>
+              <a:buNone/>
+            </a:pPr>
+            <a:r>
+              <a:rPr lang="en-US" sz="1200" dirty="0">
                 <a:solidFill>
                   <a:srgbClr val="0B1220"/>
                 </a:solidFill>
@@ -4830,38 +6401,21 @@
                 <a:ea typeface="Inter" pitchFamily="34" charset="-122"/>
                 <a:cs typeface="Inter" pitchFamily="34" charset="-120"/>
               </a:rPr>
-              <a:t>Cada equipo decide solo.</a:t>
-            </a:r>
-            <a:pPr algn="l" indent="0" marL="0">
-              <a:lnSpc>
-                <a:spcPct val="116000"/>
-              </a:lnSpc>
-              <a:buNone/>
-            </a:pPr>
-            <a:r>
-              <a:rPr lang="en-US" sz="1250" dirty="0">
-                <a:solidFill>
-                  <a:srgbClr val="0B1220"/>
-                </a:solidFill>
-                <a:latin typeface="Inter" pitchFamily="34" charset="0"/>
-                <a:ea typeface="Inter" pitchFamily="34" charset="-122"/>
-                <a:cs typeface="Inter" pitchFamily="34" charset="-120"/>
-              </a:rPr>
-              <a:t> No hay límite de mensajes por persona ni calendario común: Marketing, Product Growth y Sales le escriben a la misma gente el mismo día.</a:t>
-            </a:r>
-            <a:endParaRPr lang="en-US" sz="1250" dirty="0"/>
-          </a:p>
-        </p:txBody>
-      </p:sp>
-      <p:sp>
-        <p:nvSpPr>
-          <p:cNvPr id="20" name="Shape 18"/>
+              <a:t>Canvas tiene un grupo de control real</a:t>
+            </a:r>
+            <a:endParaRPr lang="en-US" sz="1200" dirty="0"/>
+          </a:p>
+        </p:txBody>
+      </p:sp>
+      <p:sp>
+        <p:nvSpPr>
+          <p:cNvPr id="12" name="Shape 10"/>
           <p:cNvSpPr/>
           <p:nvPr/>
         </p:nvSpPr>
         <p:spPr>
           <a:xfrm>
-            <a:off x="8152111" y="2784184"/>
+            <a:off x="511956" y="2784184"/>
             <a:ext cx="3527477" cy="0"/>
           </a:xfrm>
           <a:prstGeom prst="line">
@@ -4878,13 +6432,13 @@
       </p:sp>
       <p:sp>
         <p:nvSpPr>
-          <p:cNvPr id="21" name="Shape 19"/>
+          <p:cNvPr id="13" name="Shape 11"/>
           <p:cNvSpPr/>
           <p:nvPr/>
         </p:nvSpPr>
         <p:spPr>
           <a:xfrm>
-            <a:off x="8152111" y="2922987"/>
+            <a:off x="511956" y="2922987"/>
             <a:ext cx="231639" cy="231639"/>
           </a:xfrm>
           <a:prstGeom prst="ellipse">
@@ -4898,13 +6452,13 @@
       </p:sp>
       <p:sp>
         <p:nvSpPr>
-          <p:cNvPr id="22" name="Text 20"/>
-          <p:cNvSpPr txBox="1"/>
-          <p:nvPr/>
-        </p:nvSpPr>
-        <p:spPr>
-          <a:xfrm>
-            <a:off x="8152111" y="2922987"/>
+          <p:cNvPr id="14" name="Text 12"/>
+          <p:cNvSpPr txBox="1"/>
+          <p:nvPr/>
+        </p:nvSpPr>
+        <p:spPr>
+          <a:xfrm>
+            <a:off x="511956" y="2922987"/>
             <a:ext cx="256876" cy="231639"/>
           </a:xfrm>
           <a:prstGeom prst="rect">
@@ -4932,7 +6486,7 @@
                 <a:ea typeface="Inter" pitchFamily="34" charset="-122"/>
                 <a:cs typeface="Inter" pitchFamily="34" charset="-120"/>
               </a:rPr>
-              <a:t>3</a:t>
+              <a:t>1</a:t>
             </a:r>
             <a:endParaRPr lang="en-US" sz="960" dirty="0"/>
           </a:p>
@@ -4940,13 +6494,13 @@
       </p:sp>
       <p:sp>
         <p:nvSpPr>
-          <p:cNvPr id="23" name="Text 21"/>
-          <p:cNvSpPr txBox="1"/>
-          <p:nvPr/>
-        </p:nvSpPr>
-        <p:spPr>
-          <a:xfrm>
-            <a:off x="8493465" y="2922987"/>
+          <p:cNvPr id="15" name="Text 13"/>
+          <p:cNvSpPr txBox="1"/>
+          <p:nvPr/>
+        </p:nvSpPr>
+        <p:spPr>
+          <a:xfrm>
+            <a:off x="853310" y="2922987"/>
             <a:ext cx="3299995" cy="1109213"/>
           </a:xfrm>
           <a:prstGeom prst="rect">
@@ -4974,7 +6528,7 @@
                 <a:ea typeface="Inter" pitchFamily="34" charset="-122"/>
                 <a:cs typeface="Inter" pitchFamily="34" charset="-120"/>
               </a:rPr>
-              <a:t>Nadie compara volumen contra respuesta.</a:t>
+              <a:t>Escribimos por lo que queremos vender.</a:t>
             </a:r>
             <a:pPr algn="l" indent="0" marL="0">
               <a:lnSpc>
@@ -4991,7 +6545,7 @@
                 <a:ea typeface="Inter" pitchFamily="34" charset="-122"/>
                 <a:cs typeface="Inter" pitchFamily="34" charset="-120"/>
               </a:rPr>
-              <a:t> Copiar una campaña cada mes es más fácil que medirla: 4 de cada 10 mensajes salen de campañas debajo del mínimo.</a:t>
+              <a:t> Las promociones salen a listas por etapa, no por lo que la persona hizo, y le seguimos escribiendo a quien no responde.</a:t>
             </a:r>
             <a:endParaRPr lang="en-US" sz="1250" dirty="0"/>
           </a:p>
@@ -4999,16 +6553,39 @@
       </p:sp>
       <p:sp>
         <p:nvSpPr>
-          <p:cNvPr id="24" name="Shape 22"/>
+          <p:cNvPr id="16" name="Shape 14"/>
           <p:cNvSpPr/>
           <p:nvPr/>
         </p:nvSpPr>
         <p:spPr>
           <a:xfrm>
-            <a:off x="511956" y="5992160"/>
-            <a:ext cx="11167783" cy="352808"/>
-          </a:xfrm>
-          <a:prstGeom prst="rect">
+            <a:off x="4331958" y="2784184"/>
+            <a:ext cx="3527628" cy="0"/>
+          </a:xfrm>
+          <a:prstGeom prst="line">
+            <a:avLst/>
+          </a:prstGeom>
+          <a:noFill/>
+          <a:ln w="9645">
+            <a:solidFill>
+              <a:srgbClr val="DDE2EA"/>
+            </a:solidFill>
+            <a:prstDash val="solid"/>
+          </a:ln>
+        </p:spPr>
+      </p:sp>
+      <p:sp>
+        <p:nvSpPr>
+          <p:cNvPr id="17" name="Shape 15"/>
+          <p:cNvSpPr/>
+          <p:nvPr/>
+        </p:nvSpPr>
+        <p:spPr>
+          <a:xfrm>
+            <a:off x="4331958" y="2922987"/>
+            <a:ext cx="231639" cy="231639"/>
+          </a:xfrm>
+          <a:prstGeom prst="ellipse">
             <a:avLst/>
           </a:prstGeom>
           <a:solidFill>
@@ -5019,6 +6596,271 @@
       </p:sp>
       <p:sp>
         <p:nvSpPr>
+          <p:cNvPr id="18" name="Text 16"/>
+          <p:cNvSpPr txBox="1"/>
+          <p:nvPr/>
+        </p:nvSpPr>
+        <p:spPr>
+          <a:xfrm>
+            <a:off x="4331958" y="2922987"/>
+            <a:ext cx="256876" cy="231639"/>
+          </a:xfrm>
+          <a:prstGeom prst="rect">
+            <a:avLst/>
+          </a:prstGeom>
+          <a:noFill/>
+          <a:ln/>
+        </p:spPr>
+        <p:txBody>
+          <a:bodyPr wrap="square" lIns="0" tIns="0" rIns="0" bIns="0" rtlCol="0" anchor="ctr"/>
+          <a:lstStyle/>
+          <a:p>
+            <a:pPr algn="ctr" indent="0" marL="0">
+              <a:lnSpc>
+                <a:spcPct val="112000"/>
+              </a:lnSpc>
+              <a:buNone/>
+            </a:pPr>
+            <a:r>
+              <a:rPr lang="en-US" sz="960" b="1" dirty="0">
+                <a:solidFill>
+                  <a:srgbClr val="1F4FD8"/>
+                </a:solidFill>
+                <a:latin typeface="Inter" pitchFamily="34" charset="0"/>
+                <a:ea typeface="Inter" pitchFamily="34" charset="-122"/>
+                <a:cs typeface="Inter" pitchFamily="34" charset="-120"/>
+              </a:rPr>
+              <a:t>2</a:t>
+            </a:r>
+            <a:endParaRPr lang="en-US" sz="960" dirty="0"/>
+          </a:p>
+        </p:txBody>
+      </p:sp>
+      <p:sp>
+        <p:nvSpPr>
+          <p:cNvPr id="19" name="Text 17"/>
+          <p:cNvSpPr txBox="1"/>
+          <p:nvPr/>
+        </p:nvSpPr>
+        <p:spPr>
+          <a:xfrm>
+            <a:off x="4673312" y="2922987"/>
+            <a:ext cx="3300150" cy="1109213"/>
+          </a:xfrm>
+          <a:prstGeom prst="rect">
+            <a:avLst/>
+          </a:prstGeom>
+          <a:noFill/>
+          <a:ln/>
+        </p:spPr>
+        <p:txBody>
+          <a:bodyPr wrap="square" lIns="0" tIns="0" rIns="0" bIns="0" rtlCol="0" anchor="t"/>
+          <a:lstStyle/>
+          <a:p>
+            <a:pPr algn="l" indent="0" marL="0">
+              <a:lnSpc>
+                <a:spcPct val="116000"/>
+              </a:lnSpc>
+              <a:buNone/>
+            </a:pPr>
+            <a:r>
+              <a:rPr lang="en-US" sz="1250" b="1" dirty="0">
+                <a:solidFill>
+                  <a:srgbClr val="0B1220"/>
+                </a:solidFill>
+                <a:latin typeface="Inter" pitchFamily="34" charset="0"/>
+                <a:ea typeface="Inter" pitchFamily="34" charset="-122"/>
+                <a:cs typeface="Inter" pitchFamily="34" charset="-120"/>
+              </a:rPr>
+              <a:t>Cada equipo decide solo.</a:t>
+            </a:r>
+            <a:pPr algn="l" indent="0" marL="0">
+              <a:lnSpc>
+                <a:spcPct val="116000"/>
+              </a:lnSpc>
+              <a:buNone/>
+            </a:pPr>
+            <a:r>
+              <a:rPr lang="en-US" sz="1250" dirty="0">
+                <a:solidFill>
+                  <a:srgbClr val="0B1220"/>
+                </a:solidFill>
+                <a:latin typeface="Inter" pitchFamily="34" charset="0"/>
+                <a:ea typeface="Inter" pitchFamily="34" charset="-122"/>
+                <a:cs typeface="Inter" pitchFamily="34" charset="-120"/>
+              </a:rPr>
+              <a:t> No hay límite de mensajes por persona ni calendario común: Marketing, Product Growth y Sales le escriben a la misma gente el mismo día.</a:t>
+            </a:r>
+            <a:endParaRPr lang="en-US" sz="1250" dirty="0"/>
+          </a:p>
+        </p:txBody>
+      </p:sp>
+      <p:sp>
+        <p:nvSpPr>
+          <p:cNvPr id="20" name="Shape 18"/>
+          <p:cNvSpPr/>
+          <p:nvPr/>
+        </p:nvSpPr>
+        <p:spPr>
+          <a:xfrm>
+            <a:off x="8152111" y="2784184"/>
+            <a:ext cx="3527477" cy="0"/>
+          </a:xfrm>
+          <a:prstGeom prst="line">
+            <a:avLst/>
+          </a:prstGeom>
+          <a:noFill/>
+          <a:ln w="9645">
+            <a:solidFill>
+              <a:srgbClr val="DDE2EA"/>
+            </a:solidFill>
+            <a:prstDash val="solid"/>
+          </a:ln>
+        </p:spPr>
+      </p:sp>
+      <p:sp>
+        <p:nvSpPr>
+          <p:cNvPr id="21" name="Shape 19"/>
+          <p:cNvSpPr/>
+          <p:nvPr/>
+        </p:nvSpPr>
+        <p:spPr>
+          <a:xfrm>
+            <a:off x="8152111" y="2922987"/>
+            <a:ext cx="231639" cy="231639"/>
+          </a:xfrm>
+          <a:prstGeom prst="ellipse">
+            <a:avLst/>
+          </a:prstGeom>
+          <a:solidFill>
+            <a:srgbClr val="E8EEFC"/>
+          </a:solidFill>
+          <a:ln/>
+        </p:spPr>
+      </p:sp>
+      <p:sp>
+        <p:nvSpPr>
+          <p:cNvPr id="22" name="Text 20"/>
+          <p:cNvSpPr txBox="1"/>
+          <p:nvPr/>
+        </p:nvSpPr>
+        <p:spPr>
+          <a:xfrm>
+            <a:off x="8152111" y="2922987"/>
+            <a:ext cx="256876" cy="231639"/>
+          </a:xfrm>
+          <a:prstGeom prst="rect">
+            <a:avLst/>
+          </a:prstGeom>
+          <a:noFill/>
+          <a:ln/>
+        </p:spPr>
+        <p:txBody>
+          <a:bodyPr wrap="square" lIns="0" tIns="0" rIns="0" bIns="0" rtlCol="0" anchor="ctr"/>
+          <a:lstStyle/>
+          <a:p>
+            <a:pPr algn="ctr" indent="0" marL="0">
+              <a:lnSpc>
+                <a:spcPct val="112000"/>
+              </a:lnSpc>
+              <a:buNone/>
+            </a:pPr>
+            <a:r>
+              <a:rPr lang="en-US" sz="960" b="1" dirty="0">
+                <a:solidFill>
+                  <a:srgbClr val="1F4FD8"/>
+                </a:solidFill>
+                <a:latin typeface="Inter" pitchFamily="34" charset="0"/>
+                <a:ea typeface="Inter" pitchFamily="34" charset="-122"/>
+                <a:cs typeface="Inter" pitchFamily="34" charset="-120"/>
+              </a:rPr>
+              <a:t>3</a:t>
+            </a:r>
+            <a:endParaRPr lang="en-US" sz="960" dirty="0"/>
+          </a:p>
+        </p:txBody>
+      </p:sp>
+      <p:sp>
+        <p:nvSpPr>
+          <p:cNvPr id="23" name="Text 21"/>
+          <p:cNvSpPr txBox="1"/>
+          <p:nvPr/>
+        </p:nvSpPr>
+        <p:spPr>
+          <a:xfrm>
+            <a:off x="8493465" y="2922987"/>
+            <a:ext cx="3299995" cy="1109213"/>
+          </a:xfrm>
+          <a:prstGeom prst="rect">
+            <a:avLst/>
+          </a:prstGeom>
+          <a:noFill/>
+          <a:ln/>
+        </p:spPr>
+        <p:txBody>
+          <a:bodyPr wrap="square" lIns="0" tIns="0" rIns="0" bIns="0" rtlCol="0" anchor="t"/>
+          <a:lstStyle/>
+          <a:p>
+            <a:pPr algn="l" indent="0" marL="0">
+              <a:lnSpc>
+                <a:spcPct val="116000"/>
+              </a:lnSpc>
+              <a:buNone/>
+            </a:pPr>
+            <a:r>
+              <a:rPr lang="en-US" sz="1250" b="1" dirty="0">
+                <a:solidFill>
+                  <a:srgbClr val="0B1220"/>
+                </a:solidFill>
+                <a:latin typeface="Inter" pitchFamily="34" charset="0"/>
+                <a:ea typeface="Inter" pitchFamily="34" charset="-122"/>
+                <a:cs typeface="Inter" pitchFamily="34" charset="-120"/>
+              </a:rPr>
+              <a:t>Nadie compara volumen contra respuesta.</a:t>
+            </a:r>
+            <a:pPr algn="l" indent="0" marL="0">
+              <a:lnSpc>
+                <a:spcPct val="116000"/>
+              </a:lnSpc>
+              <a:buNone/>
+            </a:pPr>
+            <a:r>
+              <a:rPr lang="en-US" sz="1250" dirty="0">
+                <a:solidFill>
+                  <a:srgbClr val="0B1220"/>
+                </a:solidFill>
+                <a:latin typeface="Inter" pitchFamily="34" charset="0"/>
+                <a:ea typeface="Inter" pitchFamily="34" charset="-122"/>
+                <a:cs typeface="Inter" pitchFamily="34" charset="-120"/>
+              </a:rPr>
+              <a:t> Copiar una campaña cada mes es más fácil que medirla: 4 de cada 10 mensajes salen de campañas debajo del mínimo.</a:t>
+            </a:r>
+            <a:endParaRPr lang="en-US" sz="1250" dirty="0"/>
+          </a:p>
+        </p:txBody>
+      </p:sp>
+      <p:sp>
+        <p:nvSpPr>
+          <p:cNvPr id="24" name="Shape 22"/>
+          <p:cNvSpPr/>
+          <p:nvPr/>
+        </p:nvSpPr>
+        <p:spPr>
+          <a:xfrm>
+            <a:off x="511956" y="5992160"/>
+            <a:ext cx="11167783" cy="352808"/>
+          </a:xfrm>
+          <a:prstGeom prst="rect">
+            <a:avLst/>
+          </a:prstGeom>
+          <a:solidFill>
+            <a:srgbClr val="E8EEFC"/>
+          </a:solidFill>
+          <a:ln/>
+        </p:spPr>
+      </p:sp>
+      <p:sp>
+        <p:nvSpPr>
           <p:cNvPr id="25" name="Text 23"/>
           <p:cNvSpPr txBox="1"/>
           <p:nvPr/>
@@ -5151,8 +6993,8 @@
         </p:nvSpPr>
         <p:spPr>
           <a:xfrm>
-            <a:off x="11570777" y="6454684"/>
-            <a:ext cx="130519" cy="135035"/>
+            <a:off x="11569873" y="6454684"/>
+            <a:ext cx="131450" cy="135035"/>
           </a:xfrm>
           <a:prstGeom prst="rect">
             <a:avLst/>
@@ -5179,7 +7021,7 @@
                 <a:ea typeface="Inter" pitchFamily="34" charset="-122"/>
                 <a:cs typeface="Inter" pitchFamily="34" charset="-120"/>
               </a:rPr>
-              <a:t>12</a:t>
+              <a:t>13</a:t>
             </a:r>
             <a:endParaRPr lang="en-US" sz="840" dirty="0"/>
           </a:p>

</xml_diff>

<commit_message>
Deck Marketing: tres formas de gráfica distintas y lámina del teléfono (EN)
- 2: dispersión gasto contra MXN por conversión, con recta y R².
- 12: franja de puntos por problema de orden (se queda).
- 13: Pareto acumulado de campañas que escriben a quien no debía.
- en/phone_slide: tres casos vistos desde el teléfono, cifras corregidas.

Co-Authored-By: Claude Opus 5.5 <noreply@anthropic.com>
Claude-Session: https://claude.ai/code/session_01TvUEpjnhb8DCD8seX9ZHQA
</commit_message>
<xml_diff>
--- a/braze-analysis/deck/v6/marketing/DECK_marketing.pptx
+++ b/braze-analysis/deck/v6/marketing/DECK_marketing.pptx
@@ -120,7 +120,7 @@
   <p:extLst>
     <p:ext uri="{521415D9-36F7-43E2-AB2F-B90AF26B5E84}">
       <p14:sectionLst xmlns:p14="http://schemas.microsoft.com/office/powerpoint/2010/main">
-        <p14:section name="Inicio" id="{badf1b25-0407-8db2-0ed6-86b3f297fb1c}">
+        <p14:section name="Inicio" id="{e18a75f4-633e-c07c-b14c-833b099ea460}">
           <p14:sldIdLst>
             <p14:sldId id="256"/>
             <p14:sldId id="257"/>
@@ -6463,7 +6463,7 @@
                 <a:ea typeface="Inter" pitchFamily="34" charset="-122"/>
                 <a:cs typeface="Inter" pitchFamily="34" charset="-120"/>
               </a:rPr>
-              <a:t>Cada punto es una campaña que mandó promociones a un grupo que no debería recibirlas</a:t>
+              <a:t>502 campañas mandaron promociones a quien no debía recibirlas; las 10 primeras suman solo 24 %</a:t>
             </a:r>
             <a:endParaRPr lang="en-US" sz="960" dirty="0"/>
           </a:p>
@@ -6486,7 +6486,7 @@
         <p:spPr>
           <a:xfrm>
             <a:off x="511956" y="3523107"/>
-            <a:ext cx="6742235" cy="2235606"/>
+            <a:ext cx="6742235" cy="2380889"/>
           </a:xfrm>
           <a:prstGeom prst="rect">
             <a:avLst/>
@@ -8839,7 +8839,7 @@
                 <a:ea typeface="Inter" pitchFamily="34" charset="-122"/>
                 <a:cs typeface="Inter" pitchFamily="34" charset="-120"/>
               </a:rPr>
-              <a:t>Cada punto es una campaña con 20 mil MXN o más: MXN por conversión, por equipo</a:t>
+              <a:t>Cada punto es una campaña con 20 mil MXN o más: gasto contra MXN por conversión</a:t>
             </a:r>
             <a:endParaRPr lang="en-US" sz="960" dirty="0"/>
           </a:p>
@@ -8862,7 +8862,7 @@
         <p:spPr>
           <a:xfrm>
             <a:off x="511956" y="3351902"/>
-            <a:ext cx="5981008" cy="2266501"/>
+            <a:ext cx="5981159" cy="2392494"/>
           </a:xfrm>
           <a:prstGeom prst="rect">
             <a:avLst/>
@@ -9007,7 +9007,7 @@
                 <a:ea typeface="Inter" pitchFamily="34" charset="-122"/>
                 <a:cs typeface="Inter" pitchFamily="34" charset="-120"/>
               </a:rPr>
-              <a:t> La campaña típica de Marketing paga 128 MXN por conversión; la de Product Growth, 47. Tasa 0 a rezagados, 460.</a:t>
+              <a:t> La campaña típica de Marketing paga 128 MXN por conversión; la del resto, 34. Gastar más no la abarata (R² 0.03).</a:t>
             </a:r>
             <a:endParaRPr lang="en-US" sz="1060" dirty="0"/>
           </a:p>

</xml_diff>

<commit_message>
Deck Marketing: gráficas sin puntos en 2, 13 y 14
- 2: curvas acumuladas de gasto contra conversiones de Marketing.
- 13: mapa campaña por mes de las 13 campañas con más versiones.
- 14: barras de las 30 campañas con más promociones a quien no debía,
  con línea acumulada.

Co-Authored-By: Claude Opus 5.5 <noreply@anthropic.com>
Claude-Session: https://claude.ai/code/session_01TvUEpjnhb8DCD8seX9ZHQA
</commit_message>
<xml_diff>
--- a/braze-analysis/deck/v6/marketing/DECK_marketing.pptx
+++ b/braze-analysis/deck/v6/marketing/DECK_marketing.pptx
@@ -121,7 +121,7 @@
   <p:extLst>
     <p:ext uri="{521415D9-36F7-43E2-AB2F-B90AF26B5E84}">
       <p14:sectionLst xmlns:p14="http://schemas.microsoft.com/office/powerpoint/2010/main">
-        <p14:section name="Inicio" id="{9ed9d948-b8e3-76d5-6a96-2a0294e6a1b6}">
+        <p14:section name="Inicio" id="{7c664dc1-3743-8b88-25b4-d2ec0fa60e18}">
           <p14:sldIdLst>
             <p14:sldId id="256"/>
             <p14:sldId id="257"/>
@@ -6031,7 +6031,7 @@
                 <a:ea typeface="Inter" pitchFamily="34" charset="-122"/>
                 <a:cs typeface="Inter" pitchFamily="34" charset="-120"/>
               </a:rPr>
-              <a:t>Cada punto es una comunicación que mandó algo en 2026, por problema de orden</a:t>
+              <a:t>Las 13 campañas con más versiones: casi cada mes se estrena una copia nueva</a:t>
             </a:r>
             <a:endParaRPr lang="en-US" sz="960" dirty="0"/>
           </a:p>
@@ -6054,7 +6054,7 @@
         <p:spPr>
           <a:xfrm>
             <a:off x="511956" y="2771676"/>
-            <a:ext cx="6959858" cy="2930522"/>
+            <a:ext cx="6960009" cy="2979804"/>
           </a:xfrm>
           <a:prstGeom prst="rect">
             <a:avLst/>
@@ -7609,7 +7609,7 @@
                 <a:ea typeface="Inter" pitchFamily="34" charset="-122"/>
                 <a:cs typeface="Inter" pitchFamily="34" charset="-120"/>
               </a:rPr>
-              <a:t>502 campañas mandaron promociones a quien no debía recibirlas; las 10 primeras suman solo 24 %</a:t>
+              <a:t>Las 30 campañas que más promociones mandaron a quien no debía: 44 % de lo que mandaron 502</a:t>
             </a:r>
             <a:endParaRPr lang="en-US" sz="960" dirty="0"/>
           </a:p>
@@ -7632,7 +7632,7 @@
         <p:spPr>
           <a:xfrm>
             <a:off x="511956" y="3523107"/>
-            <a:ext cx="6742235" cy="2380889"/>
+            <a:ext cx="6742235" cy="2486234"/>
           </a:xfrm>
           <a:prstGeom prst="rect">
             <a:avLst/>
@@ -9985,7 +9985,7 @@
                 <a:ea typeface="Inter" pitchFamily="34" charset="-122"/>
                 <a:cs typeface="Inter" pitchFamily="34" charset="-120"/>
               </a:rPr>
-              <a:t>Cada punto es una campaña con 20 mil MXN o más: gasto contra MXN por conversión</a:t>
+              <a:t>Campañas de Marketing de la que más gasta a la que menos: gasto contra conversiones acumuladas</a:t>
             </a:r>
             <a:endParaRPr lang="en-US" sz="960" dirty="0"/>
           </a:p>
@@ -10153,7 +10153,7 @@
                 <a:ea typeface="Inter" pitchFamily="34" charset="-122"/>
                 <a:cs typeface="Inter" pitchFamily="34" charset="-120"/>
               </a:rPr>
-              <a:t> La campaña típica de Marketing paga 128 MXN por conversión; la del resto, 34. Gastar más no la abarata (R² 0.03).</a:t>
+              <a:t> Cinco campañas son 46 % del gasto de Marketing y traen 23 % de sus conversiones; la mayor, Tasa 0 a rezagados.</a:t>
             </a:r>
             <a:endParaRPr lang="en-US" sz="1060" dirty="0"/>
           </a:p>

</xml_diff>